<commit_message>
docs: add live demo QR to pitch deck
</commit_message>
<xml_diff>
--- a/assets/QueryForge-Pitch.pptx
+++ b/assets/QueryForge-Pitch.pptx
@@ -3514,7 +3514,7 @@
         <p:spPr>
           <a:xfrm>
             <a:off x="1188720" y="4160520"/>
-            <a:ext cx="9966960" cy="1188720"/>
+            <a:ext cx="6446520" cy="1188720"/>
           </a:xfrm>
           <a:prstGeom prst="rect">
             <a:avLst/>
@@ -3528,71 +3528,74 @@
           <a:lstStyle/>
           <a:p>
             <a:pPr algn="l">
-              <a:spcAft>
-                <a:spcPts val="800"/>
-              </a:spcAft>
-            </a:pPr>
-            <a:r>
-              <a:rPr sz="1300" b="0">
-                <a:solidFill>
-                  <a:srgbClr val="4EA8DE"/>
-                </a:solidFill>
-                <a:latin typeface="Arial"/>
-                <a:ea typeface="Microsoft YaHei"/>
+              <a:lnSpc>
+                <a:spcPct val="112000"/>
+              </a:lnSpc>
+              <a:spcAft>
+                <a:spcPts val="800"/>
+              </a:spcAft>
+            </a:pPr>
+            <a:r>
+              <a:rPr b="1" sz="1500">
+                <a:solidFill>
+                  <a:srgbClr val="D4A853"/>
+                </a:solidFill>
+                <a:latin typeface="Microsoft YaHei"/>
+                <a:ea typeface="Microsoft YaHei"/>
+                <a:cs typeface="Microsoft YaHei"/>
               </a:rPr>
               <a:t>在线演示：queryforge-production-8d6f.up.railway.app</a:t>
             </a:r>
           </a:p>
           <a:p>
-            <a:pPr algn="l">
-              <a:spcAft>
-                <a:spcPts val="800"/>
-              </a:spcAft>
-            </a:pPr>
-            <a:r>
-              <a:rPr sz="1300" b="0">
-                <a:solidFill>
-                  <a:srgbClr val="4EA8DE"/>
-                </a:solidFill>
-                <a:latin typeface="Arial"/>
-                <a:ea typeface="Microsoft YaHei"/>
+            <a:pPr>
+              <a:spcAft>
+                <a:spcPts val="700"/>
+              </a:spcAft>
+            </a:pPr>
+            <a:r>
+              <a:rPr b="1" sz="1400">
+                <a:solidFill>
+                  <a:srgbClr val="C8C4BC"/>
+                </a:solidFill>
+                <a:latin typeface="Microsoft YaHei"/>
+                <a:ea typeface="Microsoft YaHei"/>
+                <a:cs typeface="Microsoft YaHei"/>
               </a:rPr>
               <a:t>GitHub：github.com/eric-stone-plus/queryforge</a:t>
             </a:r>
           </a:p>
           <a:p>
-            <a:pPr algn="l">
-              <a:spcAft>
-                <a:spcPts val="800"/>
-              </a:spcAft>
-            </a:pPr>
-            <a:r>
-              <a:rPr sz="1300" b="0">
-                <a:solidFill>
-                  <a:srgbClr val="F0EEE8"/>
-                </a:solidFill>
-                <a:latin typeface="Arial"/>
-                <a:ea typeface="Microsoft YaHei"/>
-              </a:rPr>
-              <a:t/>
-            </a:r>
-          </a:p>
-          <a:p>
-            <a:pPr algn="l">
-              <a:spcAft>
-                <a:spcPts val="800"/>
-              </a:spcAft>
-            </a:pPr>
-            <a:r>
-              <a:rPr sz="1300" b="1">
-                <a:solidFill>
-                  <a:srgbClr val="4CAF50"/>
-                </a:solidFill>
-                <a:latin typeface="Arial"/>
-                <a:ea typeface="Microsoft YaHei"/>
-              </a:rPr>
-              <a:t>欢迎现场提问测试，真实数据实时响应</a:t>
-            </a:r>
+            <a:pPr>
+              <a:spcAft>
+                <a:spcPts val="700"/>
+              </a:spcAft>
+            </a:pPr>
+          </a:p>
+          <a:p>
+            <a:pPr>
+              <a:spcAft>
+                <a:spcPts val="600"/>
+              </a:spcAft>
+            </a:pPr>
+            <a:r>
+              <a:rPr b="1" sz="1500">
+                <a:solidFill>
+                  <a:srgbClr val="F4F1E9"/>
+                </a:solidFill>
+                <a:latin typeface="Microsoft YaHei"/>
+                <a:ea typeface="Microsoft YaHei"/>
+                <a:cs typeface="Microsoft YaHei"/>
+              </a:rPr>
+              <a:t>欢迎现场扫码体验，真实数据实时响应</a:t>
+            </a:r>
+          </a:p>
+          <a:p>
+            <a:pPr>
+              <a:spcAft>
+                <a:spcPts val="700"/>
+              </a:spcAft>
+            </a:pPr>
           </a:p>
         </p:txBody>
       </p:sp>
@@ -3628,6 +3631,243 @@
                 <a:ea typeface="Microsoft YaHei"/>
               </a:rPr>
               <a:t>ClawHunt Builder Camp 2026 · Track A: Agents at Work</a:t>
+            </a:r>
+          </a:p>
+        </p:txBody>
+      </p:sp>
+      <p:sp>
+        <p:nvSpPr>
+          <p:cNvPr id="9" name="Rectangle 8"/>
+          <p:cNvSpPr/>
+          <p:nvPr/>
+        </p:nvSpPr>
+        <p:spPr>
+          <a:xfrm>
+            <a:off x="8641080" y="3401568"/>
+            <a:ext cx="2359152" cy="2359152"/>
+          </a:xfrm>
+          <a:prstGeom prst="rect">
+            <a:avLst/>
+          </a:prstGeom>
+          <a:solidFill>
+            <a:srgbClr val="2A2F3E"/>
+          </a:solidFill>
+          <a:ln w="12700">
+            <a:solidFill>
+              <a:srgbClr val="3B4356"/>
+            </a:solidFill>
+          </a:ln>
+        </p:spPr>
+        <p:style>
+          <a:lnRef idx="1">
+            <a:schemeClr val="accent1"/>
+          </a:lnRef>
+          <a:fillRef idx="3">
+            <a:schemeClr val="accent1"/>
+          </a:fillRef>
+          <a:effectRef idx="2">
+            <a:schemeClr val="accent1"/>
+          </a:effectRef>
+          <a:fontRef idx="minor">
+            <a:schemeClr val="lt1"/>
+          </a:fontRef>
+        </p:style>
+        <p:txBody>
+          <a:bodyPr rtlCol="0" anchor="ctr"/>
+          <a:lstStyle/>
+          <a:p>
+            <a:pPr algn="ctr"/>
+          </a:p>
+        </p:txBody>
+      </p:sp>
+      <p:sp>
+        <p:nvSpPr>
+          <p:cNvPr id="10" name="Rectangle 9"/>
+          <p:cNvSpPr/>
+          <p:nvPr/>
+        </p:nvSpPr>
+        <p:spPr>
+          <a:xfrm>
+            <a:off x="8833104" y="3593592"/>
+            <a:ext cx="1975104" cy="1975104"/>
+          </a:xfrm>
+          <a:prstGeom prst="rect">
+            <a:avLst/>
+          </a:prstGeom>
+          <a:solidFill>
+            <a:srgbClr val="FFFFFF"/>
+          </a:solidFill>
+          <a:ln>
+            <a:solidFill>
+              <a:srgbClr val="FFFFFF"/>
+            </a:solidFill>
+          </a:ln>
+        </p:spPr>
+        <p:style>
+          <a:lnRef idx="1">
+            <a:schemeClr val="accent1"/>
+          </a:lnRef>
+          <a:fillRef idx="3">
+            <a:schemeClr val="accent1"/>
+          </a:fillRef>
+          <a:effectRef idx="2">
+            <a:schemeClr val="accent1"/>
+          </a:effectRef>
+          <a:fontRef idx="minor">
+            <a:schemeClr val="lt1"/>
+          </a:fontRef>
+        </p:style>
+        <p:txBody>
+          <a:bodyPr rtlCol="0" anchor="ctr"/>
+          <a:lstStyle/>
+          <a:p>
+            <a:pPr algn="ctr"/>
+          </a:p>
+        </p:txBody>
+      </p:sp>
+      <p:pic>
+        <p:nvPicPr>
+          <p:cNvPr id="11" name="Picture 10" descr="railway-demo-qr.png"/>
+          <p:cNvPicPr>
+            <a:picLocks noChangeAspect="1"/>
+          </p:cNvPicPr>
+          <p:nvPr/>
+        </p:nvPicPr>
+        <p:blipFill>
+          <a:blip r:embed="rId2"/>
+          <a:stretch>
+            <a:fillRect/>
+          </a:stretch>
+        </p:blipFill>
+        <p:spPr>
+          <a:xfrm>
+            <a:off x="8887968" y="3648456"/>
+            <a:ext cx="1865376" cy="1865376"/>
+          </a:xfrm>
+          <a:prstGeom prst="rect">
+            <a:avLst/>
+          </a:prstGeom>
+        </p:spPr>
+      </p:pic>
+      <p:sp>
+        <p:nvSpPr>
+          <p:cNvPr id="12" name="TextBox 11"/>
+          <p:cNvSpPr txBox="1"/>
+          <p:nvPr/>
+        </p:nvSpPr>
+        <p:spPr>
+          <a:xfrm>
+            <a:off x="8641080" y="2962656"/>
+            <a:ext cx="2359152" cy="256032"/>
+          </a:xfrm>
+          <a:prstGeom prst="rect">
+            <a:avLst/>
+          </a:prstGeom>
+          <a:noFill/>
+        </p:spPr>
+        <p:txBody>
+          <a:bodyPr wrap="square" anchor="t" lIns="0" rIns="0" tIns="0" bIns="0">
+            <a:spAutoFit/>
+          </a:bodyPr>
+          <a:lstStyle/>
+          <a:p>
+            <a:pPr algn="ctr">
+              <a:lnSpc>
+                <a:spcPct val="108000"/>
+              </a:lnSpc>
+            </a:pPr>
+            <a:r>
+              <a:rPr sz="1400" b="1">
+                <a:solidFill>
+                  <a:srgbClr val="D4A853"/>
+                </a:solidFill>
+                <a:latin typeface="Microsoft YaHei"/>
+                <a:ea typeface="Microsoft YaHei"/>
+                <a:cs typeface="Microsoft YaHei"/>
+              </a:rPr>
+              <a:t>扫码体验</a:t>
+            </a:r>
+          </a:p>
+        </p:txBody>
+      </p:sp>
+      <p:sp>
+        <p:nvSpPr>
+          <p:cNvPr id="13" name="TextBox 12"/>
+          <p:cNvSpPr txBox="1"/>
+          <p:nvPr/>
+        </p:nvSpPr>
+        <p:spPr>
+          <a:xfrm>
+            <a:off x="8558784" y="5833872"/>
+            <a:ext cx="2514600" cy="201168"/>
+          </a:xfrm>
+          <a:prstGeom prst="rect">
+            <a:avLst/>
+          </a:prstGeom>
+          <a:noFill/>
+        </p:spPr>
+        <p:txBody>
+          <a:bodyPr wrap="square" anchor="t" lIns="0" rIns="0" tIns="0" bIns="0">
+            <a:spAutoFit/>
+          </a:bodyPr>
+          <a:lstStyle/>
+          <a:p>
+            <a:pPr algn="ctr">
+              <a:lnSpc>
+                <a:spcPct val="108000"/>
+              </a:lnSpc>
+            </a:pPr>
+            <a:r>
+              <a:rPr sz="980" b="1">
+                <a:solidFill>
+                  <a:srgbClr val="9A9A9A"/>
+                </a:solidFill>
+                <a:latin typeface="Microsoft YaHei"/>
+                <a:ea typeface="Microsoft YaHei"/>
+                <a:cs typeface="Microsoft YaHei"/>
+              </a:rPr>
+              <a:t>Railway 在线演示</a:t>
+            </a:r>
+          </a:p>
+        </p:txBody>
+      </p:sp>
+      <p:sp>
+        <p:nvSpPr>
+          <p:cNvPr id="14" name="TextBox 13"/>
+          <p:cNvSpPr txBox="1"/>
+          <p:nvPr/>
+        </p:nvSpPr>
+        <p:spPr>
+          <a:xfrm>
+            <a:off x="8302752" y="6053328"/>
+            <a:ext cx="3054096" cy="201168"/>
+          </a:xfrm>
+          <a:prstGeom prst="rect">
+            <a:avLst/>
+          </a:prstGeom>
+          <a:noFill/>
+        </p:spPr>
+        <p:txBody>
+          <a:bodyPr wrap="square" anchor="t" lIns="0" rIns="0" tIns="0" bIns="0">
+            <a:spAutoFit/>
+          </a:bodyPr>
+          <a:lstStyle/>
+          <a:p>
+            <a:pPr algn="ctr">
+              <a:lnSpc>
+                <a:spcPct val="108000"/>
+              </a:lnSpc>
+            </a:pPr>
+            <a:r>
+              <a:rPr sz="800" b="0">
+                <a:solidFill>
+                  <a:srgbClr val="C8C4BC"/>
+                </a:solidFill>
+                <a:latin typeface="Microsoft YaHei"/>
+                <a:ea typeface="Microsoft YaHei"/>
+                <a:cs typeface="Microsoft YaHei"/>
+              </a:rPr>
+              <a:t>queryforge-production-8d6f.up.railway.app</a:t>
             </a:r>
           </a:p>
         </p:txBody>

</xml_diff>

<commit_message>
feat: polish QueryForge demo and public release
</commit_message>
<xml_diff>
--- a/assets/QueryForge-Pitch.pptx
+++ b/assets/QueryForge-Pitch.pptx
@@ -114,1056 +114,6 @@
     </a:lvl9pPr>
   </p:defaultTextStyle>
 </p:presentation>
-</file>
-
-<file path=ppt/notesMasters/notesMaster1.xml><?xml version="1.0" encoding="utf-8"?>
-<p:notesMaster xmlns:a="http://schemas.openxmlformats.org/drawingml/2006/main" xmlns:p="http://schemas.openxmlformats.org/presentationml/2006/main" xmlns:r="http://schemas.openxmlformats.org/officeDocument/2006/relationships">
-  <p:cSld>
-    <p:bg>
-      <p:bgRef idx="1001">
-        <a:schemeClr val="bg1"/>
-      </p:bgRef>
-    </p:bg>
-    <p:spTree>
-      <p:nvGrpSpPr>
-        <p:cNvPr id="1" name=""/>
-        <p:cNvGrpSpPr/>
-        <p:nvPr/>
-      </p:nvGrpSpPr>
-      <p:grpSpPr>
-        <a:xfrm>
-          <a:off x="0" y="0"/>
-          <a:ext cx="0" cy="0"/>
-          <a:chOff x="0" y="0"/>
-          <a:chExt cx="0" cy="0"/>
-        </a:xfrm>
-      </p:grpSpPr>
-      <p:sp>
-        <p:nvSpPr>
-          <p:cNvPr id="2" name="Header Placeholder 1"/>
-          <p:cNvSpPr>
-            <a:spLocks noGrp="1"/>
-          </p:cNvSpPr>
-          <p:nvPr>
-            <p:ph type="hdr" sz="quarter"/>
-          </p:nvPr>
-        </p:nvSpPr>
-        <p:spPr>
-          <a:xfrm>
-            <a:off x="0" y="0"/>
-            <a:ext cx="2971800" cy="457200"/>
-          </a:xfrm>
-          <a:prstGeom prst="rect">
-            <a:avLst/>
-          </a:prstGeom>
-        </p:spPr>
-        <p:txBody>
-          <a:bodyPr vert="horz" lIns="91440" tIns="45720" rIns="91440" bIns="45720" rtlCol="0"/>
-          <a:lstStyle>
-            <a:lvl1pPr algn="l">
-              <a:defRPr sz="1200"/>
-            </a:lvl1pPr>
-          </a:lstStyle>
-          <a:p>
-            <a:endParaRPr lang="en-US"/>
-          </a:p>
-        </p:txBody>
-      </p:sp>
-      <p:sp>
-        <p:nvSpPr>
-          <p:cNvPr id="3" name="Date Placeholder 2"/>
-          <p:cNvSpPr>
-            <a:spLocks noGrp="1"/>
-          </p:cNvSpPr>
-          <p:nvPr>
-            <p:ph type="dt" idx="1"/>
-          </p:nvPr>
-        </p:nvSpPr>
-        <p:spPr>
-          <a:xfrm>
-            <a:off x="3884613" y="0"/>
-            <a:ext cx="2971800" cy="457200"/>
-          </a:xfrm>
-          <a:prstGeom prst="rect">
-            <a:avLst/>
-          </a:prstGeom>
-        </p:spPr>
-        <p:txBody>
-          <a:bodyPr vert="horz" lIns="91440" tIns="45720" rIns="91440" bIns="45720" rtlCol="0"/>
-          <a:lstStyle>
-            <a:lvl1pPr algn="r">
-              <a:defRPr sz="1200"/>
-            </a:lvl1pPr>
-          </a:lstStyle>
-          <a:p>
-            <a:fld id="{0F89C1C7-3DCD-1040-A9CF-14679D8B5DDD}" type="datetimeFigureOut">
-              <a:rPr lang="en-US" smtClean="0"/>
-              <a:t>10/17/16</a:t>
-            </a:fld>
-            <a:endParaRPr lang="en-US"/>
-          </a:p>
-        </p:txBody>
-      </p:sp>
-      <p:sp>
-        <p:nvSpPr>
-          <p:cNvPr id="4" name="Slide Image Placeholder 3"/>
-          <p:cNvSpPr>
-            <a:spLocks noGrp="1" noRot="1" noChangeAspect="1"/>
-          </p:cNvSpPr>
-          <p:nvPr>
-            <p:ph type="sldImg" idx="2"/>
-          </p:nvPr>
-        </p:nvSpPr>
-        <p:spPr>
-          <a:xfrm>
-            <a:off x="1143000" y="685800"/>
-            <a:ext cx="4572000" cy="3429000"/>
-          </a:xfrm>
-          <a:prstGeom prst="rect">
-            <a:avLst/>
-          </a:prstGeom>
-          <a:noFill/>
-          <a:ln w="12700">
-            <a:solidFill>
-              <a:prstClr val="black"/>
-            </a:solidFill>
-          </a:ln>
-        </p:spPr>
-        <p:txBody>
-          <a:bodyPr vert="horz" lIns="91440" tIns="45720" rIns="91440" bIns="45720" rtlCol="0" anchor="ctr"/>
-          <a:lstStyle/>
-          <a:p>
-            <a:endParaRPr lang="en-US"/>
-          </a:p>
-        </p:txBody>
-      </p:sp>
-      <p:sp>
-        <p:nvSpPr>
-          <p:cNvPr id="5" name="Notes Placeholder 4"/>
-          <p:cNvSpPr>
-            <a:spLocks noGrp="1"/>
-          </p:cNvSpPr>
-          <p:nvPr>
-            <p:ph type="body" sz="quarter" idx="3"/>
-          </p:nvPr>
-        </p:nvSpPr>
-        <p:spPr>
-          <a:xfrm>
-            <a:off x="685800" y="4343400"/>
-            <a:ext cx="5486400" cy="4114800"/>
-          </a:xfrm>
-          <a:prstGeom prst="rect">
-            <a:avLst/>
-          </a:prstGeom>
-        </p:spPr>
-        <p:txBody>
-          <a:bodyPr vert="horz" lIns="91440" tIns="45720" rIns="91440" bIns="45720" rtlCol="0"/>
-          <a:lstStyle/>
-          <a:p>
-            <a:pPr lvl="0"/>
-            <a:r>
-              <a:rPr lang="en-US" smtClean="0"/>
-              <a:t>Click to edit Master text styles</a:t>
-            </a:r>
-          </a:p>
-          <a:p>
-            <a:pPr lvl="1"/>
-            <a:r>
-              <a:rPr lang="en-US" smtClean="0"/>
-              <a:t>Second level</a:t>
-            </a:r>
-          </a:p>
-          <a:p>
-            <a:pPr lvl="2"/>
-            <a:r>
-              <a:rPr lang="en-US" smtClean="0"/>
-              <a:t>Third level</a:t>
-            </a:r>
-          </a:p>
-          <a:p>
-            <a:pPr lvl="3"/>
-            <a:r>
-              <a:rPr lang="en-US" smtClean="0"/>
-              <a:t>Fourth level</a:t>
-            </a:r>
-          </a:p>
-          <a:p>
-            <a:pPr lvl="4"/>
-            <a:r>
-              <a:rPr lang="en-US" smtClean="0"/>
-              <a:t>Fifth level</a:t>
-            </a:r>
-            <a:endParaRPr lang="en-US"/>
-          </a:p>
-        </p:txBody>
-      </p:sp>
-      <p:sp>
-        <p:nvSpPr>
-          <p:cNvPr id="6" name="Footer Placeholder 5"/>
-          <p:cNvSpPr>
-            <a:spLocks noGrp="1"/>
-          </p:cNvSpPr>
-          <p:nvPr>
-            <p:ph type="ftr" sz="quarter" idx="4"/>
-          </p:nvPr>
-        </p:nvSpPr>
-        <p:spPr>
-          <a:xfrm>
-            <a:off x="0" y="8685213"/>
-            <a:ext cx="2971800" cy="457200"/>
-          </a:xfrm>
-          <a:prstGeom prst="rect">
-            <a:avLst/>
-          </a:prstGeom>
-        </p:spPr>
-        <p:txBody>
-          <a:bodyPr vert="horz" lIns="91440" tIns="45720" rIns="91440" bIns="45720" rtlCol="0" anchor="b"/>
-          <a:lstStyle>
-            <a:lvl1pPr algn="l">
-              <a:defRPr sz="1200"/>
-            </a:lvl1pPr>
-          </a:lstStyle>
-          <a:p>
-            <a:endParaRPr lang="en-US"/>
-          </a:p>
-        </p:txBody>
-      </p:sp>
-      <p:sp>
-        <p:nvSpPr>
-          <p:cNvPr id="7" name="Slide Number Placeholder 6"/>
-          <p:cNvSpPr>
-            <a:spLocks noGrp="1"/>
-          </p:cNvSpPr>
-          <p:nvPr>
-            <p:ph type="sldNum" sz="quarter" idx="5"/>
-          </p:nvPr>
-        </p:nvSpPr>
-        <p:spPr>
-          <a:xfrm>
-            <a:off x="3884613" y="8685213"/>
-            <a:ext cx="2971800" cy="457200"/>
-          </a:xfrm>
-          <a:prstGeom prst="rect">
-            <a:avLst/>
-          </a:prstGeom>
-        </p:spPr>
-        <p:txBody>
-          <a:bodyPr vert="horz" lIns="91440" tIns="45720" rIns="91440" bIns="45720" rtlCol="0" anchor="b"/>
-          <a:lstStyle>
-            <a:lvl1pPr algn="r">
-              <a:defRPr sz="1200"/>
-            </a:lvl1pPr>
-          </a:lstStyle>
-          <a:p>
-            <a:fld id="{BB5E49A5-4136-284D-997B-48E1D791AD67}" type="slidenum">
-              <a:rPr lang="en-US" smtClean="0"/>
-              <a:t>‹#›</a:t>
-            </a:fld>
-            <a:endParaRPr lang="en-US"/>
-          </a:p>
-        </p:txBody>
-      </p:sp>
-    </p:spTree>
-    <p:extLst>
-      <p:ext uri="{BB962C8B-B14F-4D97-AF65-F5344CB8AC3E}">
-        <p14:creationId xmlns:p14="http://schemas.microsoft.com/office/powerpoint/2010/main" val="2623252185"/>
-      </p:ext>
-    </p:extLst>
-  </p:cSld>
-  <p:clrMap bg1="lt1" tx1="dk1" bg2="lt2" tx2="dk2" accent1="accent1" accent2="accent2" accent3="accent3" accent4="accent4" accent5="accent5" accent6="accent6" hlink="hlink" folHlink="folHlink"/>
-  <p:notesStyle>
-    <a:lvl1pPr marL="0" algn="l" defTabSz="457200" rtl="0" eaLnBrk="1" latinLnBrk="0" hangingPunct="1">
-      <a:defRPr sz="1200" kern="1200">
-        <a:solidFill>
-          <a:schemeClr val="tx1"/>
-        </a:solidFill>
-        <a:latin typeface="+mn-lt"/>
-        <a:ea typeface="+mn-ea"/>
-        <a:cs typeface="+mn-cs"/>
-      </a:defRPr>
-    </a:lvl1pPr>
-    <a:lvl2pPr marL="457200" algn="l" defTabSz="457200" rtl="0" eaLnBrk="1" latinLnBrk="0" hangingPunct="1">
-      <a:defRPr sz="1200" kern="1200">
-        <a:solidFill>
-          <a:schemeClr val="tx1"/>
-        </a:solidFill>
-        <a:latin typeface="+mn-lt"/>
-        <a:ea typeface="+mn-ea"/>
-        <a:cs typeface="+mn-cs"/>
-      </a:defRPr>
-    </a:lvl2pPr>
-    <a:lvl3pPr marL="914400" algn="l" defTabSz="457200" rtl="0" eaLnBrk="1" latinLnBrk="0" hangingPunct="1">
-      <a:defRPr sz="1200" kern="1200">
-        <a:solidFill>
-          <a:schemeClr val="tx1"/>
-        </a:solidFill>
-        <a:latin typeface="+mn-lt"/>
-        <a:ea typeface="+mn-ea"/>
-        <a:cs typeface="+mn-cs"/>
-      </a:defRPr>
-    </a:lvl3pPr>
-    <a:lvl4pPr marL="1371600" algn="l" defTabSz="457200" rtl="0" eaLnBrk="1" latinLnBrk="0" hangingPunct="1">
-      <a:defRPr sz="1200" kern="1200">
-        <a:solidFill>
-          <a:schemeClr val="tx1"/>
-        </a:solidFill>
-        <a:latin typeface="+mn-lt"/>
-        <a:ea typeface="+mn-ea"/>
-        <a:cs typeface="+mn-cs"/>
-      </a:defRPr>
-    </a:lvl4pPr>
-    <a:lvl5pPr marL="1828800" algn="l" defTabSz="457200" rtl="0" eaLnBrk="1" latinLnBrk="0" hangingPunct="1">
-      <a:defRPr sz="1200" kern="1200">
-        <a:solidFill>
-          <a:schemeClr val="tx1"/>
-        </a:solidFill>
-        <a:latin typeface="+mn-lt"/>
-        <a:ea typeface="+mn-ea"/>
-        <a:cs typeface="+mn-cs"/>
-      </a:defRPr>
-    </a:lvl5pPr>
-    <a:lvl6pPr marL="2286000" algn="l" defTabSz="457200" rtl="0" eaLnBrk="1" latinLnBrk="0" hangingPunct="1">
-      <a:defRPr sz="1200" kern="1200">
-        <a:solidFill>
-          <a:schemeClr val="tx1"/>
-        </a:solidFill>
-        <a:latin typeface="+mn-lt"/>
-        <a:ea typeface="+mn-ea"/>
-        <a:cs typeface="+mn-cs"/>
-      </a:defRPr>
-    </a:lvl6pPr>
-    <a:lvl7pPr marL="2743200" algn="l" defTabSz="457200" rtl="0" eaLnBrk="1" latinLnBrk="0" hangingPunct="1">
-      <a:defRPr sz="1200" kern="1200">
-        <a:solidFill>
-          <a:schemeClr val="tx1"/>
-        </a:solidFill>
-        <a:latin typeface="+mn-lt"/>
-        <a:ea typeface="+mn-ea"/>
-        <a:cs typeface="+mn-cs"/>
-      </a:defRPr>
-    </a:lvl7pPr>
-    <a:lvl8pPr marL="3200400" algn="l" defTabSz="457200" rtl="0" eaLnBrk="1" latinLnBrk="0" hangingPunct="1">
-      <a:defRPr sz="1200" kern="1200">
-        <a:solidFill>
-          <a:schemeClr val="tx1"/>
-        </a:solidFill>
-        <a:latin typeface="+mn-lt"/>
-        <a:ea typeface="+mn-ea"/>
-        <a:cs typeface="+mn-cs"/>
-      </a:defRPr>
-    </a:lvl8pPr>
-    <a:lvl9pPr marL="3657600" algn="l" defTabSz="457200" rtl="0" eaLnBrk="1" latinLnBrk="0" hangingPunct="1">
-      <a:defRPr sz="1200" kern="1200">
-        <a:solidFill>
-          <a:schemeClr val="tx1"/>
-        </a:solidFill>
-        <a:latin typeface="+mn-lt"/>
-        <a:ea typeface="+mn-ea"/>
-        <a:cs typeface="+mn-cs"/>
-      </a:defRPr>
-    </a:lvl9pPr>
-  </p:notesStyle>
-</p:notesMaster>
-</file>
-
-<file path=ppt/notesSlides/notesSlide1.xml><?xml version="1.0" encoding="utf-8"?>
-<p:notes xmlns:a="http://schemas.openxmlformats.org/drawingml/2006/main" xmlns:p="http://schemas.openxmlformats.org/presentationml/2006/main" xmlns:r="http://schemas.openxmlformats.org/officeDocument/2006/relationships">
-  <p:cSld>
-    <p:spTree>
-      <p:nvGrpSpPr>
-        <p:cNvPr id="1" name=""/>
-        <p:cNvGrpSpPr/>
-        <p:nvPr/>
-      </p:nvGrpSpPr>
-      <p:grpSpPr>
-        <a:xfrm>
-          <a:off x="0" y="0"/>
-          <a:ext cx="0" cy="0"/>
-          <a:chOff x="0" y="0"/>
-          <a:chExt cx="0" cy="0"/>
-        </a:xfrm>
-      </p:grpSpPr>
-      <p:sp>
-        <p:nvSpPr>
-          <p:cNvPr id="2" name="Slide Image Placeholder 1"/>
-          <p:cNvSpPr>
-            <a:spLocks noGrp="1"/>
-          </p:cNvSpPr>
-          <p:nvPr>
-            <p:ph type="sldImg" idx="2"/>
-          </p:nvPr>
-        </p:nvSpPr>
-        <p:spPr/>
-      </p:sp>
-      <p:sp>
-        <p:nvSpPr>
-          <p:cNvPr id="3" name="Notes Placeholder 2"/>
-          <p:cNvSpPr>
-            <a:spLocks noGrp="1"/>
-          </p:cNvSpPr>
-          <p:nvPr>
-            <p:ph type="body" idx="3" sz="quarter"/>
-          </p:nvPr>
-        </p:nvSpPr>
-        <p:spPr/>
-        <p:txBody>
-          <a:bodyPr/>
-          <a:lstStyle/>
-          <a:p>
-            <a:r>
-              <a:t>大家好，我是 QueryForge 的开发者。QueryForge 是一个 AI 数据分析智能体，让业务团队用自然语言直接提问。我们用 Kaggle 上 Olist 巴西电商的真实数据——99,441 笔订单——做了完整验证。不要提模型名和框架。</a:t>
-            </a:r>
-          </a:p>
-        </p:txBody>
-      </p:sp>
-      <p:sp>
-        <p:nvSpPr>
-          <p:cNvPr id="4" name="Slide Number Placeholder 3"/>
-          <p:cNvSpPr>
-            <a:spLocks noGrp="1"/>
-          </p:cNvSpPr>
-          <p:nvPr>
-            <p:ph type="sldNum" idx="5" sz="quarter"/>
-          </p:nvPr>
-        </p:nvSpPr>
-        <p:spPr/>
-      </p:sp>
-    </p:spTree>
-  </p:cSld>
-  <p:clrMapOvr>
-    <a:masterClrMapping/>
-  </p:clrMapOvr>
-</p:notes>
-</file>
-
-<file path=ppt/notesSlides/notesSlide10.xml><?xml version="1.0" encoding="utf-8"?>
-<p:notes xmlns:a="http://schemas.openxmlformats.org/drawingml/2006/main" xmlns:p="http://schemas.openxmlformats.org/presentationml/2006/main" xmlns:r="http://schemas.openxmlformats.org/officeDocument/2006/relationships">
-  <p:cSld>
-    <p:spTree>
-      <p:nvGrpSpPr>
-        <p:cNvPr id="1" name=""/>
-        <p:cNvGrpSpPr/>
-        <p:nvPr/>
-      </p:nvGrpSpPr>
-      <p:grpSpPr>
-        <a:xfrm>
-          <a:off x="0" y="0"/>
-          <a:ext cx="0" cy="0"/>
-          <a:chOff x="0" y="0"/>
-          <a:chExt cx="0" cy="0"/>
-        </a:xfrm>
-      </p:grpSpPr>
-      <p:sp>
-        <p:nvSpPr>
-          <p:cNvPr id="2" name="Slide Image Placeholder 1"/>
-          <p:cNvSpPr>
-            <a:spLocks noGrp="1"/>
-          </p:cNvSpPr>
-          <p:nvPr>
-            <p:ph type="sldImg" idx="2"/>
-          </p:nvPr>
-        </p:nvSpPr>
-        <p:spPr/>
-      </p:sp>
-      <p:sp>
-        <p:nvSpPr>
-          <p:cNvPr id="3" name="Notes Placeholder 2"/>
-          <p:cNvSpPr>
-            <a:spLocks noGrp="1"/>
-          </p:cNvSpPr>
-          <p:nvPr>
-            <p:ph type="body" idx="3" sz="quarter"/>
-          </p:nvPr>
-        </p:nvSpPr>
-        <p:spPr/>
-        <p:txBody>
-          <a:bodyPr/>
-          <a:lstStyle/>
-          <a:p>
-            <a:r>
-              <a:t>结束语：不是替代分析师，是放大10倍。扫二维码体验，GitHub开源。谢谢。指向二维码。时间允许可现场开演示。</a:t>
-            </a:r>
-          </a:p>
-        </p:txBody>
-      </p:sp>
-      <p:sp>
-        <p:nvSpPr>
-          <p:cNvPr id="4" name="Slide Number Placeholder 3"/>
-          <p:cNvSpPr>
-            <a:spLocks noGrp="1"/>
-          </p:cNvSpPr>
-          <p:nvPr>
-            <p:ph type="sldNum" idx="5" sz="quarter"/>
-          </p:nvPr>
-        </p:nvSpPr>
-        <p:spPr/>
-      </p:sp>
-    </p:spTree>
-  </p:cSld>
-  <p:clrMapOvr>
-    <a:masterClrMapping/>
-  </p:clrMapOvr>
-</p:notes>
-</file>
-
-<file path=ppt/notesSlides/notesSlide2.xml><?xml version="1.0" encoding="utf-8"?>
-<p:notes xmlns:a="http://schemas.openxmlformats.org/drawingml/2006/main" xmlns:p="http://schemas.openxmlformats.org/presentationml/2006/main" xmlns:r="http://schemas.openxmlformats.org/officeDocument/2006/relationships">
-  <p:cSld>
-    <p:spTree>
-      <p:nvGrpSpPr>
-        <p:cNvPr id="1" name=""/>
-        <p:cNvGrpSpPr/>
-        <p:nvPr/>
-      </p:nvGrpSpPr>
-      <p:grpSpPr>
-        <a:xfrm>
-          <a:off x="0" y="0"/>
-          <a:ext cx="0" cy="0"/>
-          <a:chOff x="0" y="0"/>
-          <a:chExt cx="0" cy="0"/>
-        </a:xfrm>
-      </p:grpSpPr>
-      <p:sp>
-        <p:nvSpPr>
-          <p:cNvPr id="2" name="Slide Image Placeholder 1"/>
-          <p:cNvSpPr>
-            <a:spLocks noGrp="1"/>
-          </p:cNvSpPr>
-          <p:nvPr>
-            <p:ph type="sldImg" idx="2"/>
-          </p:nvPr>
-        </p:nvSpPr>
-        <p:spPr/>
-      </p:sp>
-      <p:sp>
-        <p:nvSpPr>
-          <p:cNvPr id="3" name="Notes Placeholder 2"/>
-          <p:cNvSpPr>
-            <a:spLocks noGrp="1"/>
-          </p:cNvSpPr>
-          <p:nvPr>
-            <p:ph type="body" idx="3" sz="quarter"/>
-          </p:nvPr>
-        </p:nvSpPr>
-        <p:spPr/>
-        <p:txBody>
-          <a:bodyPr/>
-          <a:lstStyle/>
-          <a:p>
-            <a:r>
-              <a:t>痛点：分析师 80% 时间在重复拉数。运营问华东卖了多少，得排队；市场问哪个品类增长最快，得等报表。关键句：痛点不是没有数据，是数据到不了需要的人手里。</a:t>
-            </a:r>
-          </a:p>
-        </p:txBody>
-      </p:sp>
-      <p:sp>
-        <p:nvSpPr>
-          <p:cNvPr id="4" name="Slide Number Placeholder 3"/>
-          <p:cNvSpPr>
-            <a:spLocks noGrp="1"/>
-          </p:cNvSpPr>
-          <p:nvPr>
-            <p:ph type="sldNum" idx="5" sz="quarter"/>
-          </p:nvPr>
-        </p:nvSpPr>
-        <p:spPr/>
-      </p:sp>
-    </p:spTree>
-  </p:cSld>
-  <p:clrMapOvr>
-    <a:masterClrMapping/>
-  </p:clrMapOvr>
-</p:notes>
-</file>
-
-<file path=ppt/notesSlides/notesSlide3.xml><?xml version="1.0" encoding="utf-8"?>
-<p:notes xmlns:a="http://schemas.openxmlformats.org/drawingml/2006/main" xmlns:p="http://schemas.openxmlformats.org/presentationml/2006/main" xmlns:r="http://schemas.openxmlformats.org/officeDocument/2006/relationships">
-  <p:cSld>
-    <p:spTree>
-      <p:nvGrpSpPr>
-        <p:cNvPr id="1" name=""/>
-        <p:cNvGrpSpPr/>
-        <p:nvPr/>
-      </p:nvGrpSpPr>
-      <p:grpSpPr>
-        <a:xfrm>
-          <a:off x="0" y="0"/>
-          <a:ext cx="0" cy="0"/>
-          <a:chOff x="0" y="0"/>
-          <a:chExt cx="0" cy="0"/>
-        </a:xfrm>
-      </p:grpSpPr>
-      <p:sp>
-        <p:nvSpPr>
-          <p:cNvPr id="2" name="Slide Image Placeholder 1"/>
-          <p:cNvSpPr>
-            <a:spLocks noGrp="1"/>
-          </p:cNvSpPr>
-          <p:nvPr>
-            <p:ph type="sldImg" idx="2"/>
-          </p:nvPr>
-        </p:nvSpPr>
-        <p:spPr/>
-      </p:sp>
-      <p:sp>
-        <p:nvSpPr>
-          <p:cNvPr id="3" name="Notes Placeholder 2"/>
-          <p:cNvSpPr>
-            <a:spLocks noGrp="1"/>
-          </p:cNvSpPr>
-          <p:nvPr>
-            <p:ph type="body" idx="3" sz="quarter"/>
-          </p:nvPr>
-        </p:nvSpPr>
-        <p:spPr/>
-        <p:txBody>
-          <a:bodyPr/>
-          <a:lstStyle/>
-          <a:p>
-            <a:r>
-              <a:t>方案：分析师定义一次指标口径，业务团队永久使用。从提需求等三天到自己问自己看。不是每次重新理解，而是一次定义永久可用。</a:t>
-            </a:r>
-          </a:p>
-        </p:txBody>
-      </p:sp>
-      <p:sp>
-        <p:nvSpPr>
-          <p:cNvPr id="4" name="Slide Number Placeholder 3"/>
-          <p:cNvSpPr>
-            <a:spLocks noGrp="1"/>
-          </p:cNvSpPr>
-          <p:nvPr>
-            <p:ph type="sldNum" idx="5" sz="quarter"/>
-          </p:nvPr>
-        </p:nvSpPr>
-        <p:spPr/>
-      </p:sp>
-    </p:spTree>
-  </p:cSld>
-  <p:clrMapOvr>
-    <a:masterClrMapping/>
-  </p:clrMapOvr>
-</p:notes>
-</file>
-
-<file path=ppt/notesSlides/notesSlide4.xml><?xml version="1.0" encoding="utf-8"?>
-<p:notes xmlns:a="http://schemas.openxmlformats.org/drawingml/2006/main" xmlns:p="http://schemas.openxmlformats.org/presentationml/2006/main" xmlns:r="http://schemas.openxmlformats.org/officeDocument/2006/relationships">
-  <p:cSld>
-    <p:spTree>
-      <p:nvGrpSpPr>
-        <p:cNvPr id="1" name=""/>
-        <p:cNvGrpSpPr/>
-        <p:nvPr/>
-      </p:nvGrpSpPr>
-      <p:grpSpPr>
-        <a:xfrm>
-          <a:off x="0" y="0"/>
-          <a:ext cx="0" cy="0"/>
-          <a:chOff x="0" y="0"/>
-          <a:chExt cx="0" cy="0"/>
-        </a:xfrm>
-      </p:grpSpPr>
-      <p:sp>
-        <p:nvSpPr>
-          <p:cNvPr id="2" name="Slide Image Placeholder 1"/>
-          <p:cNvSpPr>
-            <a:spLocks noGrp="1"/>
-          </p:cNvSpPr>
-          <p:nvPr>
-            <p:ph type="sldImg" idx="2"/>
-          </p:nvPr>
-        </p:nvSpPr>
-        <p:spPr/>
-      </p:sp>
-      <p:sp>
-        <p:nvSpPr>
-          <p:cNvPr id="3" name="Notes Placeholder 2"/>
-          <p:cNvSpPr>
-            <a:spLocks noGrp="1"/>
-          </p:cNvSpPr>
-          <p:nvPr>
-            <p:ph type="body" idx="3" sz="quarter"/>
-          </p:nvPr>
-        </p:nvSpPr>
-        <p:spPr/>
-        <p:txBody>
-          <a:bodyPr/>
-          <a:lstStyle/>
-          <a:p>
-            <a:r>
-              <a:t>四能力快速过：取数可视化、归因建议、智能纠错、指标库。不要展开，演示环节现场展示。</a:t>
-            </a:r>
-          </a:p>
-        </p:txBody>
-      </p:sp>
-      <p:sp>
-        <p:nvSpPr>
-          <p:cNvPr id="4" name="Slide Number Placeholder 3"/>
-          <p:cNvSpPr>
-            <a:spLocks noGrp="1"/>
-          </p:cNvSpPr>
-          <p:nvPr>
-            <p:ph type="sldNum" idx="5" sz="quarter"/>
-          </p:nvPr>
-        </p:nvSpPr>
-        <p:spPr/>
-      </p:sp>
-    </p:spTree>
-  </p:cSld>
-  <p:clrMapOvr>
-    <a:masterClrMapping/>
-  </p:clrMapOvr>
-</p:notes>
-</file>
-
-<file path=ppt/notesSlides/notesSlide5.xml><?xml version="1.0" encoding="utf-8"?>
-<p:notes xmlns:a="http://schemas.openxmlformats.org/drawingml/2006/main" xmlns:p="http://schemas.openxmlformats.org/presentationml/2006/main" xmlns:r="http://schemas.openxmlformats.org/officeDocument/2006/relationships">
-  <p:cSld>
-    <p:spTree>
-      <p:nvGrpSpPr>
-        <p:cNvPr id="1" name=""/>
-        <p:cNvGrpSpPr/>
-        <p:nvPr/>
-      </p:nvGrpSpPr>
-      <p:grpSpPr>
-        <a:xfrm>
-          <a:off x="0" y="0"/>
-          <a:ext cx="0" cy="0"/>
-          <a:chOff x="0" y="0"/>
-          <a:chExt cx="0" cy="0"/>
-        </a:xfrm>
-      </p:grpSpPr>
-      <p:sp>
-        <p:nvSpPr>
-          <p:cNvPr id="2" name="Slide Image Placeholder 1"/>
-          <p:cNvSpPr>
-            <a:spLocks noGrp="1"/>
-          </p:cNvSpPr>
-          <p:nvPr>
-            <p:ph type="sldImg" idx="2"/>
-          </p:nvPr>
-        </p:nvSpPr>
-        <p:spPr/>
-      </p:sp>
-      <p:sp>
-        <p:nvSpPr>
-          <p:cNvPr id="3" name="Notes Placeholder 2"/>
-          <p:cNvSpPr>
-            <a:spLocks noGrp="1"/>
-          </p:cNvSpPr>
-          <p:nvPr>
-            <p:ph type="body" idx="3" sz="quarter"/>
-          </p:nvPr>
-        </p:nvSpPr>
-        <p:spPr/>
-        <p:txBody>
-          <a:bodyPr/>
-          <a:lstStyle/>
-          <a:p>
-            <a:r>
-              <a:t>真实数据：Olist 巴西电商 99K 订单 96K 用户 74 品类。评委可随时验证——数据集公开，查询可复现。</a:t>
-            </a:r>
-          </a:p>
-        </p:txBody>
-      </p:sp>
-      <p:sp>
-        <p:nvSpPr>
-          <p:cNvPr id="4" name="Slide Number Placeholder 3"/>
-          <p:cNvSpPr>
-            <a:spLocks noGrp="1"/>
-          </p:cNvSpPr>
-          <p:nvPr>
-            <p:ph type="sldNum" idx="5" sz="quarter"/>
-          </p:nvPr>
-        </p:nvSpPr>
-        <p:spPr/>
-      </p:sp>
-    </p:spTree>
-  </p:cSld>
-  <p:clrMapOvr>
-    <a:masterClrMapping/>
-  </p:clrMapOvr>
-</p:notes>
-</file>
-
-<file path=ppt/notesSlides/notesSlide6.xml><?xml version="1.0" encoding="utf-8"?>
-<p:notes xmlns:a="http://schemas.openxmlformats.org/drawingml/2006/main" xmlns:p="http://schemas.openxmlformats.org/presentationml/2006/main" xmlns:r="http://schemas.openxmlformats.org/officeDocument/2006/relationships">
-  <p:cSld>
-    <p:spTree>
-      <p:nvGrpSpPr>
-        <p:cNvPr id="1" name=""/>
-        <p:cNvGrpSpPr/>
-        <p:nvPr/>
-      </p:nvGrpSpPr>
-      <p:grpSpPr>
-        <a:xfrm>
-          <a:off x="0" y="0"/>
-          <a:ext cx="0" cy="0"/>
-          <a:chOff x="0" y="0"/>
-          <a:chExt cx="0" cy="0"/>
-        </a:xfrm>
-      </p:grpSpPr>
-      <p:sp>
-        <p:nvSpPr>
-          <p:cNvPr id="2" name="Slide Image Placeholder 1"/>
-          <p:cNvSpPr>
-            <a:spLocks noGrp="1"/>
-          </p:cNvSpPr>
-          <p:nvPr>
-            <p:ph type="sldImg" idx="2"/>
-          </p:nvPr>
-        </p:nvSpPr>
-        <p:spPr/>
-      </p:sp>
-      <p:sp>
-        <p:nvSpPr>
-          <p:cNvPr id="3" name="Notes Placeholder 2"/>
-          <p:cNvSpPr>
-            <a:spLocks noGrp="1"/>
-          </p:cNvSpPr>
-          <p:nvPr>
-            <p:ph type="body" idx="3" sz="quarter"/>
-          </p:nvPr>
-        </p:nvSpPr>
-        <p:spPr/>
-        <p:txBody>
-          <a:bodyPr/>
-          <a:lstStyle/>
-          <a:p>
-            <a:r>
-              <a:t>三层架构：受控语义层（不靠LLM猜表名）、验证式Agent循环（SQL→验证→执行→分析）、企业数据平面（Schema-only、只读、AST校验）。关键句：不是套壳ChatGPT，每层有安全边界。</a:t>
-            </a:r>
-          </a:p>
-        </p:txBody>
-      </p:sp>
-      <p:sp>
-        <p:nvSpPr>
-          <p:cNvPr id="4" name="Slide Number Placeholder 3"/>
-          <p:cNvSpPr>
-            <a:spLocks noGrp="1"/>
-          </p:cNvSpPr>
-          <p:nvPr>
-            <p:ph type="sldNum" idx="5" sz="quarter"/>
-          </p:nvPr>
-        </p:nvSpPr>
-        <p:spPr/>
-      </p:sp>
-    </p:spTree>
-  </p:cSld>
-  <p:clrMapOvr>
-    <a:masterClrMapping/>
-  </p:clrMapOvr>
-</p:notes>
-</file>
-
-<file path=ppt/notesSlides/notesSlide7.xml><?xml version="1.0" encoding="utf-8"?>
-<p:notes xmlns:a="http://schemas.openxmlformats.org/drawingml/2006/main" xmlns:p="http://schemas.openxmlformats.org/presentationml/2006/main" xmlns:r="http://schemas.openxmlformats.org/officeDocument/2006/relationships">
-  <p:cSld>
-    <p:spTree>
-      <p:nvGrpSpPr>
-        <p:cNvPr id="1" name=""/>
-        <p:cNvGrpSpPr/>
-        <p:nvPr/>
-      </p:nvGrpSpPr>
-      <p:grpSpPr>
-        <a:xfrm>
-          <a:off x="0" y="0"/>
-          <a:ext cx="0" cy="0"/>
-          <a:chOff x="0" y="0"/>
-          <a:chExt cx="0" cy="0"/>
-        </a:xfrm>
-      </p:grpSpPr>
-      <p:sp>
-        <p:nvSpPr>
-          <p:cNvPr id="2" name="Slide Image Placeholder 1"/>
-          <p:cNvSpPr>
-            <a:spLocks noGrp="1"/>
-          </p:cNvSpPr>
-          <p:nvPr>
-            <p:ph type="sldImg" idx="2"/>
-          </p:nvPr>
-        </p:nvSpPr>
-        <p:spPr/>
-      </p:sp>
-      <p:sp>
-        <p:nvSpPr>
-          <p:cNvPr id="3" name="Notes Placeholder 2"/>
-          <p:cNvSpPr>
-            <a:spLocks noGrp="1"/>
-          </p:cNvSpPr>
-          <p:nvPr>
-            <p:ph type="body" idx="3" sz="quarter"/>
-          </p:nvPr>
-        </p:nvSpPr>
-        <p:spPr/>
-        <p:txBody>
-          <a:bodyPr/>
-          <a:lstStyle/>
-          <a:p>
-            <a:r>
-              <a:t>数据合规：LLM只看Schema不看数据。SQL语法树解析只允许SELECT。数据库只读连接。生产路线图：RLS、PII脱敏、审计日志。同Snowflake Cortex和Databricks AI/BI。</a:t>
-            </a:r>
-          </a:p>
-        </p:txBody>
-      </p:sp>
-      <p:sp>
-        <p:nvSpPr>
-          <p:cNvPr id="4" name="Slide Number Placeholder 3"/>
-          <p:cNvSpPr>
-            <a:spLocks noGrp="1"/>
-          </p:cNvSpPr>
-          <p:nvPr>
-            <p:ph type="sldNum" idx="5" sz="quarter"/>
-          </p:nvPr>
-        </p:nvSpPr>
-        <p:spPr/>
-      </p:sp>
-    </p:spTree>
-  </p:cSld>
-  <p:clrMapOvr>
-    <a:masterClrMapping/>
-  </p:clrMapOvr>
-</p:notes>
-</file>
-
-<file path=ppt/notesSlides/notesSlide8.xml><?xml version="1.0" encoding="utf-8"?>
-<p:notes xmlns:a="http://schemas.openxmlformats.org/drawingml/2006/main" xmlns:p="http://schemas.openxmlformats.org/presentationml/2006/main" xmlns:r="http://schemas.openxmlformats.org/officeDocument/2006/relationships">
-  <p:cSld>
-    <p:spTree>
-      <p:nvGrpSpPr>
-        <p:cNvPr id="1" name=""/>
-        <p:cNvGrpSpPr/>
-        <p:nvPr/>
-      </p:nvGrpSpPr>
-      <p:grpSpPr>
-        <a:xfrm>
-          <a:off x="0" y="0"/>
-          <a:ext cx="0" cy="0"/>
-          <a:chOff x="0" y="0"/>
-          <a:chExt cx="0" cy="0"/>
-        </a:xfrm>
-      </p:grpSpPr>
-      <p:sp>
-        <p:nvSpPr>
-          <p:cNvPr id="2" name="Slide Image Placeholder 1"/>
-          <p:cNvSpPr>
-            <a:spLocks noGrp="1"/>
-          </p:cNvSpPr>
-          <p:nvPr>
-            <p:ph type="sldImg" idx="2"/>
-          </p:nvPr>
-        </p:nvSpPr>
-        <p:spPr/>
-      </p:sp>
-      <p:sp>
-        <p:nvSpPr>
-          <p:cNvPr id="3" name="Notes Placeholder 2"/>
-          <p:cNvSpPr>
-            <a:spLocks noGrp="1"/>
-          </p:cNvSpPr>
-          <p:nvPr>
-            <p:ph type="body" idx="3" sz="quarter"/>
-          </p:nvPr>
-        </p:nvSpPr>
-        <p:spPr/>
-        <p:txBody>
-          <a:bodyPr/>
-          <a:lstStyle/>
-          <a:p>
-            <a:r>
-              <a:t>生产路径快速过：Phase1 MVP 1-2周，Phase2 企业试用1-2月，Phase3 规模化3-6月。每查询$0.003。证明想过商业化就行。</a:t>
-            </a:r>
-          </a:p>
-        </p:txBody>
-      </p:sp>
-      <p:sp>
-        <p:nvSpPr>
-          <p:cNvPr id="4" name="Slide Number Placeholder 3"/>
-          <p:cNvSpPr>
-            <a:spLocks noGrp="1"/>
-          </p:cNvSpPr>
-          <p:nvPr>
-            <p:ph type="sldNum" idx="5" sz="quarter"/>
-          </p:nvPr>
-        </p:nvSpPr>
-        <p:spPr/>
-      </p:sp>
-    </p:spTree>
-  </p:cSld>
-  <p:clrMapOvr>
-    <a:masterClrMapping/>
-  </p:clrMapOvr>
-</p:notes>
-</file>
-
-<file path=ppt/notesSlides/notesSlide9.xml><?xml version="1.0" encoding="utf-8"?>
-<p:notes xmlns:a="http://schemas.openxmlformats.org/drawingml/2006/main" xmlns:p="http://schemas.openxmlformats.org/presentationml/2006/main" xmlns:r="http://schemas.openxmlformats.org/officeDocument/2006/relationships">
-  <p:cSld>
-    <p:spTree>
-      <p:nvGrpSpPr>
-        <p:cNvPr id="1" name=""/>
-        <p:cNvGrpSpPr/>
-        <p:nvPr/>
-      </p:nvGrpSpPr>
-      <p:grpSpPr>
-        <a:xfrm>
-          <a:off x="0" y="0"/>
-          <a:ext cx="0" cy="0"/>
-          <a:chOff x="0" y="0"/>
-          <a:chExt cx="0" cy="0"/>
-        </a:xfrm>
-      </p:grpSpPr>
-      <p:sp>
-        <p:nvSpPr>
-          <p:cNvPr id="2" name="Slide Image Placeholder 1"/>
-          <p:cNvSpPr>
-            <a:spLocks noGrp="1"/>
-          </p:cNvSpPr>
-          <p:nvPr>
-            <p:ph type="sldImg" idx="2"/>
-          </p:nvPr>
-        </p:nvSpPr>
-        <p:spPr/>
-      </p:sp>
-      <p:sp>
-        <p:nvSpPr>
-          <p:cNvPr id="3" name="Notes Placeholder 2"/>
-          <p:cNvSpPr>
-            <a:spLocks noGrp="1"/>
-          </p:cNvSpPr>
-          <p:nvPr>
-            <p:ph type="body" idx="3" sz="quarter"/>
-          </p:nvPr>
-        </p:nvSpPr>
-        <p:spPr/>
-        <p:txBody>
-          <a:bodyPr/>
-          <a:lstStyle/>
-          <a:p>
-            <a:r>
-              <a:t>双重价值：分析师减少80%重复工作变成定标准的，业务从等3天变成10秒。关键句：分析师被解放，业务被赋能。</a:t>
-            </a:r>
-          </a:p>
-        </p:txBody>
-      </p:sp>
-      <p:sp>
-        <p:nvSpPr>
-          <p:cNvPr id="4" name="Slide Number Placeholder 3"/>
-          <p:cNvSpPr>
-            <a:spLocks noGrp="1"/>
-          </p:cNvSpPr>
-          <p:nvPr>
-            <p:ph type="sldNum" idx="5" sz="quarter"/>
-          </p:nvPr>
-        </p:nvSpPr>
-        <p:spPr/>
-      </p:sp>
-    </p:spTree>
-  </p:cSld>
-  <p:clrMapOvr>
-    <a:masterClrMapping/>
-  </p:clrMapOvr>
-</p:notes>
 </file>
 
 <file path=ppt/slideLayouts/slideLayout1.xml><?xml version="1.0" encoding="utf-8"?>
@@ -4222,7 +3172,7 @@
                 <a:latin typeface="Arial"/>
                 <a:ea typeface="Microsoft YaHei"/>
               </a:rPr>
-              <a:t>AI 数据分析智能体 · 让业务团队自助取数</a:t>
+              <a:t>受治理的自助式商业分析层</a:t>
             </a:r>
           </a:p>
         </p:txBody>
@@ -4258,7 +3208,7 @@
                 <a:latin typeface="Arial"/>
                 <a:ea typeface="Microsoft YaHei"/>
               </a:rPr>
-              <a:t>ClawHunt Builder Camp 2026 · 72 小时构建</a:t>
+              <a:t>ClawHunt Builder Camp 2026 · Track C: Business on AI</a:t>
             </a:r>
           </a:p>
         </p:txBody>
@@ -4294,7 +3244,7 @@
                 <a:latin typeface="Arial"/>
                 <a:ea typeface="Microsoft YaHei"/>
               </a:rPr>
-              <a:t>基于 Olist 真实电商数据（99,441 笔订单）验证</a:t>
+              <a:t>通用商业分析工具 · Olist 作为本次 demo case</a:t>
             </a:r>
           </a:p>
         </p:txBody>
@@ -4406,7 +3356,7 @@
         <p:spPr>
           <a:xfrm>
             <a:off x="914400" y="3017520"/>
-            <a:ext cx="9144000" cy="731520"/>
+            <a:ext cx="7680960" cy="731520"/>
           </a:xfrm>
           <a:prstGeom prst="rect">
             <a:avLst/>
@@ -4428,8 +3378,8 @@
                 <a:latin typeface="Arial"/>
                 <a:ea typeface="Microsoft YaHei"/>
               </a:rPr>
-              <a:t>受控的对话式分析层
-不是让 AI 替代分析师，而是让分析师的能力通过 AI 放大 10 倍</a:t>
+              <a:t>受治理的自助式商业分析层
+核心口径由分析师定义，业务问题由 Agent 转成可信查询</a:t>
             </a:r>
           </a:p>
         </p:txBody>
@@ -4443,7 +3393,7 @@
         <p:spPr>
           <a:xfrm>
             <a:off x="914400" y="4389120"/>
-            <a:ext cx="9144000" cy="365760"/>
+            <a:ext cx="7498079" cy="365760"/>
           </a:xfrm>
           <a:prstGeom prst="rect">
             <a:avLst/>
@@ -4479,7 +3429,7 @@
         <p:spPr>
           <a:xfrm>
             <a:off x="914400" y="4846320"/>
-            <a:ext cx="9144000" cy="365760"/>
+            <a:ext cx="7498079" cy="365760"/>
           </a:xfrm>
           <a:prstGeom prst="rect">
             <a:avLst/>
@@ -4501,50 +3451,14 @@
                 <a:latin typeface="Arial"/>
                 <a:ea typeface="Microsoft YaHei"/>
               </a:rPr>
-              <a:t>github.com/eric-stone-plus/queryforge</a:t>
-            </a:r>
-          </a:p>
-        </p:txBody>
-      </p:sp>
-      <p:sp>
-        <p:nvSpPr>
-          <p:cNvPr id="6" name="TextBox 5"/>
-          <p:cNvSpPr txBox="1"/>
-          <p:nvPr/>
-        </p:nvSpPr>
-        <p:spPr>
-          <a:xfrm>
-            <a:off x="914400" y="5943600"/>
-            <a:ext cx="9144000" cy="365760"/>
-          </a:xfrm>
-          <a:prstGeom prst="rect">
-            <a:avLst/>
-          </a:prstGeom>
-          <a:noFill/>
-        </p:spPr>
-        <p:txBody>
-          <a:bodyPr wrap="square">
-            <a:spAutoFit/>
-          </a:bodyPr>
-          <a:lstStyle/>
-          <a:p>
-            <a:pPr algn="l"/>
-            <a:r>
-              <a:rPr sz="1100" b="0">
-                <a:solidFill>
-                  <a:srgbClr val="9A9A9A"/>
-                </a:solidFill>
-                <a:latin typeface="Arial"/>
-                <a:ea typeface="Microsoft YaHei"/>
-              </a:rPr>
-              <a:t>ClawHunt Builder Camp 2026 · Track A</a:t>
+              <a:t>github.com/eric-stone-plus/QueryForge</a:t>
             </a:r>
           </a:p>
         </p:txBody>
       </p:sp>
       <p:pic>
         <p:nvPicPr>
-          <p:cNvPr id="7" name="Picture 6" descr="qr-railway.png"/>
+          <p:cNvPr id="6" name="Picture 5" descr="qr-railway.png"/>
           <p:cNvPicPr>
             <a:picLocks noChangeAspect="1"/>
           </p:cNvPicPr>
@@ -4558,14 +3472,86 @@
         </p:blipFill>
         <p:spPr>
           <a:xfrm>
-            <a:off x="8686800" y="4114800"/>
-            <a:ext cx="1645920" cy="1645920"/>
+            <a:off x="9372600" y="3063240"/>
+            <a:ext cx="1508760" cy="1508760"/>
           </a:xfrm>
           <a:prstGeom prst="rect">
             <a:avLst/>
           </a:prstGeom>
         </p:spPr>
       </p:pic>
+      <p:sp>
+        <p:nvSpPr>
+          <p:cNvPr id="7" name="TextBox 6"/>
+          <p:cNvSpPr txBox="1"/>
+          <p:nvPr/>
+        </p:nvSpPr>
+        <p:spPr>
+          <a:xfrm>
+            <a:off x="9235440" y="4681728"/>
+            <a:ext cx="1783080" cy="320040"/>
+          </a:xfrm>
+          <a:prstGeom prst="rect">
+            <a:avLst/>
+          </a:prstGeom>
+          <a:noFill/>
+        </p:spPr>
+        <p:txBody>
+          <a:bodyPr wrap="square">
+            <a:spAutoFit/>
+          </a:bodyPr>
+          <a:lstStyle/>
+          <a:p>
+            <a:pPr algn="ctr"/>
+            <a:r>
+              <a:rPr sz="1100" b="0">
+                <a:solidFill>
+                  <a:srgbClr val="9A9A9A"/>
+                </a:solidFill>
+                <a:latin typeface="Arial"/>
+                <a:ea typeface="Microsoft YaHei"/>
+              </a:rPr>
+              <a:t>手机扫码体验</a:t>
+            </a:r>
+          </a:p>
+        </p:txBody>
+      </p:sp>
+      <p:sp>
+        <p:nvSpPr>
+          <p:cNvPr id="8" name="TextBox 7"/>
+          <p:cNvSpPr txBox="1"/>
+          <p:nvPr/>
+        </p:nvSpPr>
+        <p:spPr>
+          <a:xfrm>
+            <a:off x="914400" y="5943600"/>
+            <a:ext cx="9144000" cy="365760"/>
+          </a:xfrm>
+          <a:prstGeom prst="rect">
+            <a:avLst/>
+          </a:prstGeom>
+          <a:noFill/>
+        </p:spPr>
+        <p:txBody>
+          <a:bodyPr wrap="square">
+            <a:spAutoFit/>
+          </a:bodyPr>
+          <a:lstStyle/>
+          <a:p>
+            <a:pPr algn="l"/>
+            <a:r>
+              <a:rPr sz="1100" b="0">
+                <a:solidFill>
+                  <a:srgbClr val="9A9A9A"/>
+                </a:solidFill>
+                <a:latin typeface="Arial"/>
+                <a:ea typeface="Microsoft YaHei"/>
+              </a:rPr>
+              <a:t>ClawHunt Builder Camp 2026 · Track C: Business on AI</a:t>
+            </a:r>
+          </a:p>
+        </p:txBody>
+      </p:sp>
     </p:spTree>
   </p:cSld>
   <p:clrMapOvr>
@@ -4623,7 +3609,7 @@
                 <a:latin typeface="Arial"/>
                 <a:ea typeface="Microsoft YaHei"/>
               </a:rPr>
-              <a:t>业务要数据，总要等</a:t>
+              <a:t>业务问题越来越快，报表流程仍然很慢</a:t>
             </a:r>
           </a:p>
         </p:txBody>
@@ -4663,7 +3649,7 @@
                 <a:latin typeface="Arial"/>
                 <a:ea typeface="Microsoft YaHei"/>
               </a:rPr>
-              <a:t>  —  运营问"华东上个月卖了多少" → 找分析师排队</a:t>
+              <a:t>  —  运营问"Sudeste 的 Black Friday 峰值能否复用" → 等排期</a:t>
             </a:r>
           </a:p>
           <a:p>
@@ -4680,7 +3666,7 @@
                 <a:latin typeface="Arial"/>
                 <a:ea typeface="Microsoft YaHei"/>
               </a:rPr>
-              <a:t>  —  市场问"哪个品类增长最快" → 排期等报表</a:t>
+              <a:t>  —  市场问"哪类商品拉动新客" → 临时取数</a:t>
             </a:r>
           </a:p>
           <a:p>
@@ -4697,7 +3683,7 @@
                 <a:latin typeface="Arial"/>
                 <a:ea typeface="Microsoft YaHei"/>
               </a:rPr>
-              <a:t>  —  老板问"为什么这个月下滑" → 加急再加急</a:t>
+              <a:t>  —  老板问"本月下滑是区域、品类还是支付问题" → 加急</a:t>
             </a:r>
           </a:p>
           <a:p>
@@ -4714,7 +3700,7 @@
                 <a:latin typeface="Arial"/>
                 <a:ea typeface="Microsoft YaHei"/>
               </a:rPr>
-              <a:t>  —  同一个指标，不同部门问 10 遍，改 10 遍</a:t>
+              <a:t>  —  同一指标在不同团队反复解释，口径容易漂移</a:t>
             </a:r>
           </a:p>
         </p:txBody>
@@ -4750,7 +3736,7 @@
                 <a:latin typeface="Arial"/>
                 <a:ea typeface="Microsoft YaHei"/>
               </a:rPr>
-              <a:t>数据分析师每周 60% 时间在重复拉数，真正有价值的深度分析被挤占</a:t>
+              <a:t>现代 BI 的核心不是更多图表，而是让决策问题及时进入可信数据流程</a:t>
             </a:r>
           </a:p>
         </p:txBody>
@@ -4786,7 +3772,7 @@
                 <a:latin typeface="Arial"/>
                 <a:ea typeface="Microsoft YaHei"/>
               </a:rPr>
-              <a:t>痛点：不是没有数据，是数据到不了需要的人手里</a:t>
+              <a:t>痛点：业务侧需要速度，数据侧必须保留口径、权限和审计边界</a:t>
             </a:r>
           </a:p>
         </p:txBody>
@@ -4848,7 +3834,7 @@
                 <a:latin typeface="Arial"/>
                 <a:ea typeface="Microsoft YaHei"/>
               </a:rPr>
-              <a:t>分析师定义一次，业务自助使用</a:t>
+              <a:t>把分析师经验做成可复用语义层</a:t>
             </a:r>
           </a:p>
         </p:txBody>
@@ -4884,7 +3870,7 @@
                 <a:latin typeface="Arial"/>
                 <a:ea typeface="Microsoft YaHei"/>
               </a:rPr>
-              <a:t>核心机制：分析师把领域知识沉淀为可复用的指标资产</a:t>
+              <a:t>Managed self-service BI：核心口径受控，业务侧灵活追问</a:t>
             </a:r>
           </a:p>
         </p:txBody>
@@ -4924,7 +3910,7 @@
                 <a:latin typeface="Arial"/>
                 <a:ea typeface="Microsoft YaHei"/>
               </a:rPr>
-              <a:t>  —  分析师定义数据口径和指标（一次性工作）</a:t>
+              <a:t>  —  分析师维护指标口径、Join 关系和查询边界</a:t>
             </a:r>
           </a:p>
           <a:p>
@@ -4941,7 +3927,7 @@
                 <a:latin typeface="Arial"/>
                 <a:ea typeface="Microsoft YaHei"/>
               </a:rPr>
-              <a:t>  —  业务人员用自然语言提问，像和同事说话一样</a:t>
+              <a:t>  —  业务人员用自然语言发起问题，不需要写 SQL</a:t>
             </a:r>
           </a:p>
           <a:p>
@@ -4958,7 +3944,7 @@
                 <a:latin typeface="Arial"/>
                 <a:ea typeface="Microsoft YaHei"/>
               </a:rPr>
-              <a:t>  —  系统理解意图、匹配指标、查询数据、生成图表</a:t>
+              <a:t>  —  系统匹配语义层、执行查询、返回图表和解释</a:t>
             </a:r>
           </a:p>
           <a:p>
@@ -4975,7 +3961,7 @@
                 <a:latin typeface="Arial"/>
                 <a:ea typeface="Microsoft YaHei"/>
               </a:rPr>
-              <a:t>  —  指标可保存、可复用，口径全公司统一</a:t>
+              <a:t>  —  同一指标被复用，减少口径漂移和重复沟通</a:t>
             </a:r>
           </a:p>
         </p:txBody>
@@ -5011,7 +3997,7 @@
                 <a:latin typeface="Arial"/>
                 <a:ea typeface="Microsoft YaHei"/>
               </a:rPr>
-              <a:t>从"提需求等三天"到"自己问自己看" · 不是每次重新理解，而是一次定义永久可用</a:t>
+              <a:t>从临时报表交付，变成受治理的自助式分析</a:t>
             </a:r>
           </a:p>
         </p:txBody>
@@ -5073,7 +4059,7 @@
                 <a:latin typeface="Arial"/>
                 <a:ea typeface="Microsoft YaHei"/>
               </a:rPr>
-              <a:t>从提问到决策，一个流程走完</a:t>
+              <a:t>从静态报表到追问式分析</a:t>
             </a:r>
           </a:p>
         </p:txBody>
@@ -5152,7 +4138,7 @@
                 <a:latin typeface="Arial"/>
                 <a:ea typeface="Microsoft YaHei"/>
               </a:rPr>
-              <a:t>取数 + 可视化</a:t>
+              <a:t>描述发生了什么</a:t>
             </a:r>
           </a:p>
         </p:txBody>
@@ -5188,9 +4174,9 @@
                 <a:latin typeface="Arial"/>
                 <a:ea typeface="Microsoft YaHei"/>
               </a:rPr>
-              <a:t>"各地区本月销售额是多少"
-自动生成图表，一键切换维度
-支持柱状图、折线图、饼图、面积图</a:t>
+              <a:t>"各地区本月营收是多少"
+生成图表和明细
+按区域、品类、支付方式切换</a:t>
             </a:r>
           </a:p>
         </p:txBody>
@@ -5269,7 +4255,7 @@
                 <a:latin typeface="Arial"/>
                 <a:ea typeface="Microsoft YaHei"/>
               </a:rPr>
-              <a:t>归因 + 建议</a:t>
+              <a:t>解释为什么变化</a:t>
             </a:r>
           </a:p>
         </p:txBody>
@@ -5305,9 +4291,9 @@
                 <a:latin typeface="Arial"/>
                 <a:ea typeface="Microsoft YaHei"/>
               </a:rPr>
-              <a:t>"为什么东区下降了" → 自动找原因
-基于数据趋势给出下一步行动
-库存调整、营销策略、成本控制</a:t>
+              <a:t>"为什么 Sudeste 冲高后回落"
+比较时间、地区、品类、支付
+输出可验证的业务假设</a:t>
             </a:r>
           </a:p>
         </p:txBody>
@@ -5386,7 +4372,7 @@
                 <a:latin typeface="Arial"/>
                 <a:ea typeface="Microsoft YaHei"/>
               </a:rPr>
-              <a:t>智能纠错</a:t>
+              <a:t>验证查询可靠性</a:t>
             </a:r>
           </a:p>
         </p:txBody>
@@ -5422,9 +4408,9 @@
                 <a:latin typeface="Arial"/>
                 <a:ea typeface="Microsoft YaHei"/>
               </a:rPr>
-              <a:t>查询出错时自动诊断原因
-修正查询并重试，用户看到完整过程
-不会被错误卡住，不需要手动调试</a:t>
+              <a:t>SQL 先过 AST 安全校验
+只读执行，失败自动修正
+让错误暴露在流程里</a:t>
             </a:r>
           </a:p>
         </p:txBody>
@@ -5503,7 +4489,7 @@
                 <a:latin typeface="Arial"/>
                 <a:ea typeface="Microsoft YaHei"/>
               </a:rPr>
-              <a:t>分析师预设指标库</a:t>
+              <a:t>沉淀指标资产</a:t>
             </a:r>
           </a:p>
         </p:txBody>
@@ -5539,9 +4525,9 @@
                 <a:latin typeface="Arial"/>
                 <a:ea typeface="Microsoft YaHei"/>
               </a:rPr>
-              <a:t>分析师预先定义常用指标
-业务人员一键选择即可查询
-确保全公司使用统一的指标定义</a:t>
+              <a:t>常用问题变成指标库
+业务复用同一语义层
+形成 single version of truth</a:t>
             </a:r>
           </a:p>
         </p:txBody>
@@ -5603,7 +4589,7 @@
                 <a:latin typeface="Arial"/>
                 <a:ea typeface="Microsoft YaHei"/>
               </a:rPr>
-              <a:t>在真实数据上验证 — Olist 巴西电商平台</a:t>
+              <a:t>Demo case：Olist 巴西电商真实数据</a:t>
             </a:r>
           </a:p>
         </p:txBody>
@@ -6027,7 +5013,7 @@
                 <a:latin typeface="Arial"/>
                 <a:ea typeface="Microsoft YaHei"/>
               </a:rPr>
-              <a:t>三层架构：从 Demo 到企业级产品</a:t>
+              <a:t>Agent 的位置：把业务问题变成可治理查询</a:t>
             </a:r>
           </a:p>
         </p:txBody>
@@ -6106,7 +5092,7 @@
                 <a:latin typeface="Arial"/>
                 <a:ea typeface="Microsoft YaHei"/>
               </a:rPr>
-              <a:t>受控语义层</a:t>
+              <a:t>统一语义层</a:t>
             </a:r>
           </a:p>
         </p:txBody>
@@ -6143,9 +5129,9 @@
                 <a:ea typeface="Microsoft YaHei"/>
               </a:rPr>
               <a:t>业务语言 → 指标定义 → SQL
-不靠 LLM 猜表名
+不靠 LLM 临时猜表名
 分析师定义一次，全公司复用
-防止口径不一致</a:t>
+避免每次重新解释口径</a:t>
             </a:r>
           </a:p>
         </p:txBody>
@@ -6260,10 +5246,10 @@
                 <a:latin typeface="Arial"/>
                 <a:ea typeface="Microsoft YaHei"/>
               </a:rPr>
-              <a:t>生成 SQL → AST 验证 → 只读执行
-→ 结果分析 → 可视化
+              <a:t>理解问题 → 生成 SQL → AST 验证
+只读执行 → 读结果 → 可视化
 自纠正：出错自动修正重试
-Kimi 是推理层，不是权威</a:t>
+把取数变成可交互分析</a:t>
             </a:r>
           </a:p>
         </p:txBody>
@@ -6342,7 +5328,7 @@
                 <a:latin typeface="Arial"/>
                 <a:ea typeface="Microsoft YaHei"/>
               </a:rPr>
-              <a:t>企业数据平面</a:t>
+              <a:t>执行与治理边界</a:t>
             </a:r>
           </a:p>
         </p:txBody>
@@ -6417,7 +5403,7 @@
                 <a:latin typeface="Arial"/>
                 <a:ea typeface="Microsoft YaHei"/>
               </a:rPr>
-              <a:t>LLM 不是安全边界 · 策略引擎和执行层才是</a:t>
+              <a:t>必要性：业务问题需要解释、验证和追问；单纯 SQL 生成无法承担治理责任</a:t>
             </a:r>
           </a:p>
         </p:txBody>
@@ -6721,7 +5707,7 @@
                 <a:latin typeface="Arial"/>
                 <a:ea typeface="Microsoft YaHei"/>
               </a:rPr>
-              <a:t>从 Hackathon 到产品的路径</a:t>
+              <a:t>商业化路径：受治理的自助分析</a:t>
             </a:r>
           </a:p>
         </p:txBody>
@@ -7154,7 +6140,7 @@
                 <a:latin typeface="Arial"/>
                 <a:ea typeface="Microsoft YaHei"/>
               </a:rPr>
-              <a:t>核心指标</a:t>
+              <a:t>商业模型</a:t>
             </a:r>
           </a:p>
         </p:txBody>
@@ -7190,9 +6176,9 @@
                 <a:latin typeface="Arial"/>
                 <a:ea typeface="Microsoft YaHei"/>
               </a:rPr>
-              <a:t>每查询成本 ~$0.003（Kimi K2.7）
-单次查询延迟 2-5 秒
-从 Demo 到 MVP：1 周
+              <a:t>目标客户：数据团队、运营、市场
+付费点：席位、查询量、私有部署
+价值指标：请求周转时间、口径复用率
 从 MVP 到企业版：3 个月</a:t>
             </a:r>
           </a:p>
@@ -7255,7 +6241,7 @@
                 <a:latin typeface="Arial"/>
                 <a:ea typeface="Microsoft YaHei"/>
               </a:rPr>
-              <a:t>一个产品，两方受益</a:t>
+              <a:t>商业价值：自助速度 + 治理可信</a:t>
             </a:r>
           </a:p>
         </p:txBody>
@@ -7334,7 +6320,7 @@
                 <a:latin typeface="Arial"/>
                 <a:ea typeface="Microsoft YaHei"/>
               </a:rPr>
-              <a:t>数据分析师</a:t>
+              <a:t>数据团队</a:t>
             </a:r>
           </a:p>
         </p:txBody>
@@ -7370,10 +6356,10 @@
                 <a:latin typeface="Arial"/>
                 <a:ea typeface="Microsoft YaHei"/>
               </a:rPr>
-              <a:t>减少 80% 重复取数工作
-专注于指标定义和数据治理
-从"拉数的"变成"定标准的"
-有时间做真正有价值的深度分析</a:t>
+              <a:t>减少重复取数和口径解释
+把精力放在语义层与治理
+统一指标资产，降低审计成本
+保留权限、血缘和执行边界</a:t>
             </a:r>
           </a:p>
         </p:txBody>
@@ -7488,10 +6474,10 @@
                 <a:latin typeface="Arial"/>
                 <a:ea typeface="Microsoft YaHei"/>
               </a:rPr>
-              <a:t>随时提问，不用排队等排期
-自己看数据，自己做决策
-从"等报表"到"看数据"
-一个需求从 3 天缩短到 10 秒</a:t>
+              <a:t>不用排队等临时报表
+围绕同一数据连续追问
+在销售、投放、品类上更快试错
+从看结果转向做决策</a:t>
             </a:r>
           </a:p>
         </p:txBody>
@@ -7527,7 +6513,7 @@
                 <a:latin typeface="Arial"/>
                 <a:ea typeface="Microsoft YaHei"/>
               </a:rPr>
-              <a:t>分析师被解放，业务被赋能</a:t>
+              <a:t>不是替代分析师，而是把分析师定义的标准放进业务日常决策</a:t>
             </a:r>
           </a:p>
         </p:txBody>
@@ -7858,324 +6844,4 @@
   </a:objectDefaults>
   <a:extraClrSchemeLst/>
 </a:theme>
-</file>
-
-<file path=ppt/theme/theme2.xml><?xml version="1.0" encoding="utf-8"?>
-<a:theme xmlns:a="http://schemas.openxmlformats.org/drawingml/2006/main" name="Office Theme">
-  <a:themeElements>
-    <a:clrScheme name="Office">
-      <a:dk1>
-        <a:sysClr val="windowText" lastClr="000000"/>
-      </a:dk1>
-      <a:lt1>
-        <a:sysClr val="window" lastClr="FFFFFF"/>
-      </a:lt1>
-      <a:dk2>
-        <a:srgbClr val="1F497D"/>
-      </a:dk2>
-      <a:lt2>
-        <a:srgbClr val="EEECE1"/>
-      </a:lt2>
-      <a:accent1>
-        <a:srgbClr val="4F81BD"/>
-      </a:accent1>
-      <a:accent2>
-        <a:srgbClr val="C0504D"/>
-      </a:accent2>
-      <a:accent3>
-        <a:srgbClr val="9BBB59"/>
-      </a:accent3>
-      <a:accent4>
-        <a:srgbClr val="8064A2"/>
-      </a:accent4>
-      <a:accent5>
-        <a:srgbClr val="4BACC6"/>
-      </a:accent5>
-      <a:accent6>
-        <a:srgbClr val="F79646"/>
-      </a:accent6>
-      <a:hlink>
-        <a:srgbClr val="0000FF"/>
-      </a:hlink>
-      <a:folHlink>
-        <a:srgbClr val="800080"/>
-      </a:folHlink>
-    </a:clrScheme>
-    <a:fontScheme name="Office">
-      <a:majorFont>
-        <a:latin typeface="Calibri"/>
-        <a:ea typeface=""/>
-        <a:cs typeface=""/>
-        <a:font script="Jpan" typeface="ＭＳ Ｐゴシック"/>
-        <a:font script="Hang" typeface="맑은 고딕"/>
-        <a:font script="Hans" typeface="宋体"/>
-        <a:font script="Hant" typeface="新細明體"/>
-        <a:font script="Arab" typeface="Times New Roman"/>
-        <a:font script="Hebr" typeface="Times New Roman"/>
-        <a:font script="Thai" typeface="Angsana New"/>
-        <a:font script="Ethi" typeface="Nyala"/>
-        <a:font script="Beng" typeface="Vrinda"/>
-        <a:font script="Gujr" typeface="Shruti"/>
-        <a:font script="Khmr" typeface="MoolBoran"/>
-        <a:font script="Knda" typeface="Tunga"/>
-        <a:font script="Guru" typeface="Raavi"/>
-        <a:font script="Cans" typeface="Euphemia"/>
-        <a:font script="Cher" typeface="Plantagenet Cherokee"/>
-        <a:font script="Yiii" typeface="Microsoft Yi Baiti"/>
-        <a:font script="Tibt" typeface="Microsoft Himalaya"/>
-        <a:font script="Thaa" typeface="MV Boli"/>
-        <a:font script="Deva" typeface="Mangal"/>
-        <a:font script="Telu" typeface="Gautami"/>
-        <a:font script="Taml" typeface="Latha"/>
-        <a:font script="Syrc" typeface="Estrangelo Edessa"/>
-        <a:font script="Orya" typeface="Kalinga"/>
-        <a:font script="Mlym" typeface="Kartika"/>
-        <a:font script="Laoo" typeface="DokChampa"/>
-        <a:font script="Sinh" typeface="Iskoola Pota"/>
-        <a:font script="Mong" typeface="Mongolian Baiti"/>
-        <a:font script="Viet" typeface="Times New Roman"/>
-        <a:font script="Uigh" typeface="Microsoft Uighur"/>
-        <a:font script="Geor" typeface="Sylfaen"/>
-      </a:majorFont>
-      <a:minorFont>
-        <a:latin typeface="Calibri"/>
-        <a:ea typeface=""/>
-        <a:cs typeface=""/>
-        <a:font script="Jpan" typeface="ＭＳ Ｐゴシック"/>
-        <a:font script="Hang" typeface="맑은 고딕"/>
-        <a:font script="Hans" typeface="宋体"/>
-        <a:font script="Hant" typeface="新細明體"/>
-        <a:font script="Arab" typeface="Arial"/>
-        <a:font script="Hebr" typeface="Arial"/>
-        <a:font script="Thai" typeface="Cordia New"/>
-        <a:font script="Ethi" typeface="Nyala"/>
-        <a:font script="Beng" typeface="Vrinda"/>
-        <a:font script="Gujr" typeface="Shruti"/>
-        <a:font script="Khmr" typeface="DaunPenh"/>
-        <a:font script="Knda" typeface="Tunga"/>
-        <a:font script="Guru" typeface="Raavi"/>
-        <a:font script="Cans" typeface="Euphemia"/>
-        <a:font script="Cher" typeface="Plantagenet Cherokee"/>
-        <a:font script="Yiii" typeface="Microsoft Yi Baiti"/>
-        <a:font script="Tibt" typeface="Microsoft Himalaya"/>
-        <a:font script="Thaa" typeface="MV Boli"/>
-        <a:font script="Deva" typeface="Mangal"/>
-        <a:font script="Telu" typeface="Gautami"/>
-        <a:font script="Taml" typeface="Latha"/>
-        <a:font script="Syrc" typeface="Estrangelo Edessa"/>
-        <a:font script="Orya" typeface="Kalinga"/>
-        <a:font script="Mlym" typeface="Kartika"/>
-        <a:font script="Laoo" typeface="DokChampa"/>
-        <a:font script="Sinh" typeface="Iskoola Pota"/>
-        <a:font script="Mong" typeface="Mongolian Baiti"/>
-        <a:font script="Viet" typeface="Arial"/>
-        <a:font script="Uigh" typeface="Microsoft Uighur"/>
-        <a:font script="Geor" typeface="Sylfaen"/>
-      </a:minorFont>
-    </a:fontScheme>
-    <a:fmtScheme name="Office">
-      <a:fillStyleLst>
-        <a:solidFill>
-          <a:schemeClr val="phClr"/>
-        </a:solidFill>
-        <a:gradFill rotWithShape="1">
-          <a:gsLst>
-            <a:gs pos="0">
-              <a:schemeClr val="phClr">
-                <a:tint val="50000"/>
-                <a:satMod val="300000"/>
-              </a:schemeClr>
-            </a:gs>
-            <a:gs pos="35000">
-              <a:schemeClr val="phClr">
-                <a:tint val="37000"/>
-                <a:satMod val="300000"/>
-              </a:schemeClr>
-            </a:gs>
-            <a:gs pos="100000">
-              <a:schemeClr val="phClr">
-                <a:tint val="15000"/>
-                <a:satMod val="350000"/>
-              </a:schemeClr>
-            </a:gs>
-          </a:gsLst>
-          <a:lin ang="16200000" scaled="1"/>
-        </a:gradFill>
-        <a:gradFill rotWithShape="1">
-          <a:gsLst>
-            <a:gs pos="0">
-              <a:schemeClr val="phClr">
-                <a:tint val="100000"/>
-                <a:shade val="100000"/>
-                <a:satMod val="130000"/>
-              </a:schemeClr>
-            </a:gs>
-            <a:gs pos="100000">
-              <a:schemeClr val="phClr">
-                <a:tint val="50000"/>
-                <a:shade val="100000"/>
-                <a:satMod val="350000"/>
-              </a:schemeClr>
-            </a:gs>
-          </a:gsLst>
-          <a:lin ang="16200000" scaled="0"/>
-        </a:gradFill>
-      </a:fillStyleLst>
-      <a:lnStyleLst>
-        <a:ln w="9525" cap="flat" cmpd="sng" algn="ctr">
-          <a:solidFill>
-            <a:schemeClr val="phClr">
-              <a:shade val="95000"/>
-              <a:satMod val="105000"/>
-            </a:schemeClr>
-          </a:solidFill>
-          <a:prstDash val="solid"/>
-        </a:ln>
-        <a:ln w="25400" cap="flat" cmpd="sng" algn="ctr">
-          <a:solidFill>
-            <a:schemeClr val="phClr"/>
-          </a:solidFill>
-          <a:prstDash val="solid"/>
-        </a:ln>
-        <a:ln w="38100" cap="flat" cmpd="sng" algn="ctr">
-          <a:solidFill>
-            <a:schemeClr val="phClr"/>
-          </a:solidFill>
-          <a:prstDash val="solid"/>
-        </a:ln>
-      </a:lnStyleLst>
-      <a:effectStyleLst>
-        <a:effectStyle>
-          <a:effectLst>
-            <a:outerShdw blurRad="40000" dist="20000" dir="5400000" rotWithShape="0">
-              <a:srgbClr val="000000">
-                <a:alpha val="38000"/>
-              </a:srgbClr>
-            </a:outerShdw>
-          </a:effectLst>
-        </a:effectStyle>
-        <a:effectStyle>
-          <a:effectLst>
-            <a:outerShdw blurRad="40000" dist="23000" dir="5400000" rotWithShape="0">
-              <a:srgbClr val="000000">
-                <a:alpha val="35000"/>
-              </a:srgbClr>
-            </a:outerShdw>
-          </a:effectLst>
-        </a:effectStyle>
-        <a:effectStyle>
-          <a:effectLst>
-            <a:outerShdw blurRad="40000" dist="23000" dir="5400000" rotWithShape="0">
-              <a:srgbClr val="000000">
-                <a:alpha val="35000"/>
-              </a:srgbClr>
-            </a:outerShdw>
-          </a:effectLst>
-          <a:scene3d>
-            <a:camera prst="orthographicFront">
-              <a:rot lat="0" lon="0" rev="0"/>
-            </a:camera>
-            <a:lightRig rig="threePt" dir="t">
-              <a:rot lat="0" lon="0" rev="1200000"/>
-            </a:lightRig>
-          </a:scene3d>
-          <a:sp3d>
-            <a:bevelT w="63500" h="25400"/>
-          </a:sp3d>
-        </a:effectStyle>
-      </a:effectStyleLst>
-      <a:bgFillStyleLst>
-        <a:solidFill>
-          <a:schemeClr val="phClr"/>
-        </a:solidFill>
-        <a:gradFill rotWithShape="1">
-          <a:gsLst>
-            <a:gs pos="0">
-              <a:schemeClr val="phClr">
-                <a:tint val="40000"/>
-                <a:satMod val="350000"/>
-              </a:schemeClr>
-            </a:gs>
-            <a:gs pos="40000">
-              <a:schemeClr val="phClr">
-                <a:tint val="45000"/>
-                <a:shade val="99000"/>
-                <a:satMod val="350000"/>
-              </a:schemeClr>
-            </a:gs>
-            <a:gs pos="100000">
-              <a:schemeClr val="phClr">
-                <a:shade val="20000"/>
-                <a:satMod val="255000"/>
-              </a:schemeClr>
-            </a:gs>
-          </a:gsLst>
-          <a:path path="circle">
-            <a:fillToRect l="50000" t="-80000" r="50000" b="180000"/>
-          </a:path>
-        </a:gradFill>
-        <a:gradFill rotWithShape="1">
-          <a:gsLst>
-            <a:gs pos="0">
-              <a:schemeClr val="phClr">
-                <a:tint val="80000"/>
-                <a:satMod val="300000"/>
-              </a:schemeClr>
-            </a:gs>
-            <a:gs pos="100000">
-              <a:schemeClr val="phClr">
-                <a:shade val="30000"/>
-                <a:satMod val="200000"/>
-              </a:schemeClr>
-            </a:gs>
-          </a:gsLst>
-          <a:path path="circle">
-            <a:fillToRect l="50000" t="50000" r="50000" b="50000"/>
-          </a:path>
-        </a:gradFill>
-      </a:bgFillStyleLst>
-    </a:fmtScheme>
-  </a:themeElements>
-  <a:objectDefaults>
-    <a:spDef>
-      <a:spPr/>
-      <a:bodyPr/>
-      <a:lstStyle/>
-      <a:style>
-        <a:lnRef idx="1">
-          <a:schemeClr val="accent1"/>
-        </a:lnRef>
-        <a:fillRef idx="3">
-          <a:schemeClr val="accent1"/>
-        </a:fillRef>
-        <a:effectRef idx="2">
-          <a:schemeClr val="accent1"/>
-        </a:effectRef>
-        <a:fontRef idx="minor">
-          <a:schemeClr val="lt1"/>
-        </a:fontRef>
-      </a:style>
-    </a:spDef>
-    <a:lnDef>
-      <a:spPr/>
-      <a:bodyPr/>
-      <a:lstStyle/>
-      <a:style>
-        <a:lnRef idx="2">
-          <a:schemeClr val="accent1"/>
-        </a:lnRef>
-        <a:fillRef idx="0">
-          <a:schemeClr val="accent1"/>
-        </a:fillRef>
-        <a:effectRef idx="1">
-          <a:schemeClr val="accent1"/>
-        </a:effectRef>
-        <a:fontRef idx="minor">
-          <a:schemeClr val="tx1"/>
-        </a:fontRef>
-      </a:style>
-    </a:lnDef>
-  </a:objectDefaults>
-  <a:extraClrSchemeLst/>
-</a:theme>
 </file>
</xml_diff>

<commit_message>
feat: pivot QueryForge to local ecommerce analytics app
</commit_message>
<xml_diff>
--- a/assets/QueryForge-Pitch.pptx
+++ b/assets/QueryForge-Pitch.pptx
@@ -3172,7 +3172,7 @@
                 <a:latin typeface="Arial"/>
                 <a:ea typeface="Microsoft YaHei"/>
               </a:rPr>
-              <a:t>受治理的自助式商业分析层</a:t>
+              <a:t>让电商经营者获得专业数据分析能力</a:t>
             </a:r>
           </a:p>
         </p:txBody>
@@ -3244,7 +3244,7 @@
                 <a:latin typeface="Arial"/>
                 <a:ea typeface="Microsoft YaHei"/>
               </a:rPr>
-              <a:t>通用商业分析工具 · Olist 作为本次 demo case</a:t>
+              <a:t>面向跨境电商小团队的 local-first macOS 分析工作台</a:t>
             </a:r>
           </a:p>
         </p:txBody>
@@ -3378,8 +3378,8 @@
                 <a:latin typeface="Arial"/>
                 <a:ea typeface="Microsoft YaHei"/>
               </a:rPr>
-              <a:t>受治理的自助式商业分析层
-核心口径由分析师定义，业务问题由 Agent 转成可信查询</a:t>
+              <a:t>让电商经营者获得专业数据分析能力
+把订单、品类、渠道和复购问题变成可信查询</a:t>
             </a:r>
           </a:p>
         </p:txBody>
@@ -3415,7 +3415,7 @@
                 <a:latin typeface="Arial"/>
                 <a:ea typeface="Microsoft YaHei"/>
               </a:rPr>
-              <a:t>queryforge-production-8d6f.up.railway.app</a:t>
+              <a:t>https://queryforge-production-8d6f.up.railway.app/</a:t>
             </a:r>
           </a:p>
         </p:txBody>
@@ -3511,7 +3511,7 @@
                 <a:latin typeface="Arial"/>
                 <a:ea typeface="Microsoft YaHei"/>
               </a:rPr>
-              <a:t>手机扫码体验</a:t>
+              <a:t>扫码体验 public demo</a:t>
             </a:r>
           </a:p>
         </p:txBody>
@@ -3609,7 +3609,7 @@
                 <a:latin typeface="Arial"/>
                 <a:ea typeface="Microsoft YaHei"/>
               </a:rPr>
-              <a:t>业务问题越来越快，报表流程仍然很慢</a:t>
+              <a:t>小卖家也需要专业分析，但没有数据团队</a:t>
             </a:r>
           </a:p>
         </p:txBody>
@@ -3649,7 +3649,7 @@
                 <a:latin typeface="Arial"/>
                 <a:ea typeface="Microsoft YaHei"/>
               </a:rPr>
-              <a:t>  —  运营问"Sudeste 的 Black Friday 峰值能否复用" → 等排期</a:t>
+              <a:t>  —  店主问"哪个市场、品类和支付方式在拉动增长" → 手工导表</a:t>
             </a:r>
           </a:p>
           <a:p>
@@ -3666,7 +3666,7 @@
                 <a:latin typeface="Arial"/>
                 <a:ea typeface="Microsoft YaHei"/>
               </a:rPr>
-              <a:t>  —  市场问"哪类商品拉动新客" → 临时取数</a:t>
+              <a:t>  —  运营问"哪个商品值得继续投放" → 临时筛选订单</a:t>
             </a:r>
           </a:p>
           <a:p>
@@ -3683,7 +3683,7 @@
                 <a:latin typeface="Arial"/>
                 <a:ea typeface="Microsoft YaHei"/>
               </a:rPr>
-              <a:t>  —  老板问"本月下滑是区域、品类还是支付问题" → 加急</a:t>
+              <a:t>  —  老板问"本月下滑是品类、物流还是渠道问题" → 靠经验判断</a:t>
             </a:r>
           </a:p>
           <a:p>
@@ -3700,7 +3700,7 @@
                 <a:latin typeface="Arial"/>
                 <a:ea typeface="Microsoft YaHei"/>
               </a:rPr>
-              <a:t>  —  同一指标在不同团队反复解释，口径容易漂移</a:t>
+              <a:t>  —  广交会卖家、Amazon/marketplace 卖家和外贸 SOHO 通常不会采购 BI</a:t>
             </a:r>
           </a:p>
         </p:txBody>
@@ -3736,7 +3736,7 @@
                 <a:latin typeface="Arial"/>
                 <a:ea typeface="Microsoft YaHei"/>
               </a:rPr>
-              <a:t>现代 BI 的核心不是更多图表，而是让决策问题及时进入可信数据流程</a:t>
+              <a:t>真正的痛点不是没有数据，而是经营者缺少把订单数据变成判断的工具</a:t>
             </a:r>
           </a:p>
         </p:txBody>
@@ -3772,7 +3772,7 @@
                 <a:latin typeface="Arial"/>
                 <a:ea typeface="Microsoft YaHei"/>
               </a:rPr>
-              <a:t>痛点：业务侧需要速度，数据侧必须保留口径、权限和审计边界</a:t>
+              <a:t>痛点：跨境电商小团队需要专业分析能力，但预算、时间和技术门槛都很低</a:t>
             </a:r>
           </a:p>
         </p:txBody>
@@ -3834,7 +3834,7 @@
                 <a:latin typeface="Arial"/>
                 <a:ea typeface="Microsoft YaHei"/>
               </a:rPr>
-              <a:t>把分析师经验做成可复用语义层</a:t>
+              <a:t>把电商分析流程做成本地工作台</a:t>
             </a:r>
           </a:p>
         </p:txBody>
@@ -3870,7 +3870,7 @@
                 <a:latin typeface="Arial"/>
                 <a:ea typeface="Microsoft YaHei"/>
               </a:rPr>
-              <a:t>Managed self-service BI：核心口径受控，业务侧灵活追问</a:t>
+              <a:t>自然语言提问 → 受控 SQL → 图表 → 经营建议</a:t>
             </a:r>
           </a:p>
         </p:txBody>
@@ -3910,7 +3910,7 @@
                 <a:latin typeface="Arial"/>
                 <a:ea typeface="Microsoft YaHei"/>
               </a:rPr>
-              <a:t>  —  分析师维护指标口径、Join 关系和查询边界</a:t>
+              <a:t>  —  经营者直接问订单、品类、市场、渠道和复购问题</a:t>
             </a:r>
           </a:p>
           <a:p>
@@ -3927,7 +3927,7 @@
                 <a:latin typeface="Arial"/>
                 <a:ea typeface="Microsoft YaHei"/>
               </a:rPr>
-              <a:t>  —  业务人员用自然语言发起问题，不需要写 SQL</a:t>
+              <a:t>  —  系统生成 SQL、执行只读查询，并返回图表和解释</a:t>
             </a:r>
           </a:p>
           <a:p>
@@ -3944,7 +3944,7 @@
                 <a:latin typeface="Arial"/>
                 <a:ea typeface="Microsoft YaHei"/>
               </a:rPr>
-              <a:t>  —  系统匹配语义层、执行查询、返回图表和解释</a:t>
+              <a:t>  —  常用问题沉淀为指标，不需要每次从零分析</a:t>
             </a:r>
           </a:p>
           <a:p>
@@ -3961,7 +3961,7 @@
                 <a:latin typeface="Arial"/>
                 <a:ea typeface="Microsoft YaHei"/>
               </a:rPr>
-              <a:t>  —  同一指标被复用，减少口径漂移和重复沟通</a:t>
+              <a:t>  —  桌面 macOS app 是真实产品，数据连接与 API key 留在本机</a:t>
             </a:r>
           </a:p>
         </p:txBody>
@@ -3997,7 +3997,7 @@
                 <a:latin typeface="Arial"/>
                 <a:ea typeface="Microsoft YaHei"/>
               </a:rPr>
-              <a:t>从临时报表交付，变成受治理的自助式分析</a:t>
+              <a:t>不是做大型 BI，而是把专业分析能力降到小卖家也能使用的成本</a:t>
             </a:r>
           </a:p>
         </p:txBody>
@@ -4174,9 +4174,9 @@
                 <a:latin typeface="Arial"/>
                 <a:ea typeface="Microsoft YaHei"/>
               </a:rPr>
-              <a:t>"各地区本月营收是多少"
+              <a:t>"各市场本月营收是多少"
 生成图表和明细
-按区域、品类、支付方式切换</a:t>
+按市场、品类、支付方式切换</a:t>
             </a:r>
           </a:p>
         </p:txBody>
@@ -4291,8 +4291,8 @@
                 <a:latin typeface="Arial"/>
                 <a:ea typeface="Microsoft YaHei"/>
               </a:rPr>
-              <a:t>"为什么 Sudeste 冲高后回落"
-比较时间、地区、品类、支付
+              <a:t>"为什么某个市场冲高后回落"
+比较时间、市场、品类、支付
 输出可验证的业务假设</a:t>
             </a:r>
           </a:p>
@@ -4489,7 +4489,7 @@
                 <a:latin typeface="Arial"/>
                 <a:ea typeface="Microsoft YaHei"/>
               </a:rPr>
-              <a:t>沉淀指标资产</a:t>
+              <a:t>沉淀经营指标</a:t>
             </a:r>
           </a:p>
         </p:txBody>
@@ -4526,8 +4526,8 @@
                 <a:ea typeface="Microsoft YaHei"/>
               </a:rPr>
               <a:t>常用问题变成指标库
-业务复用同一语义层
-形成 single version of truth</a:t>
+复用同一套查询口径
+形成可追问的经营记录</a:t>
             </a:r>
           </a:p>
         </p:txBody>
@@ -4589,7 +4589,7 @@
                 <a:latin typeface="Arial"/>
                 <a:ea typeface="Microsoft YaHei"/>
               </a:rPr>
-              <a:t>Demo case：Olist 巴西电商真实数据</a:t>
+              <a:t>公开 demo：Olist 巴西电商真实数据</a:t>
             </a:r>
           </a:p>
         </p:txBody>
@@ -4898,7 +4898,7 @@
                 <a:latin typeface="Arial"/>
                 <a:ea typeface="Microsoft YaHei"/>
               </a:rPr>
-              <a:t>  —  覆盖巴西5大地区，2016-2018年完整时间序列</a:t>
+              <a:t>  —  覆盖巴西公开交易样本，2016-2018年完整时间序列</a:t>
             </a:r>
           </a:p>
           <a:p>
@@ -4951,7 +4951,7 @@
                 <a:latin typeface="Arial"/>
                 <a:ea typeface="Microsoft YaHei"/>
               </a:rPr>
-              <a:t>Olist Brazilian E-Commerce Public Dataset · Kaggle 最受欢迎电商数据集之一</a:t>
+              <a:t>Railway / iPhone QR 是 polished public demo；完整产品是本地 macOS app</a:t>
             </a:r>
           </a:p>
         </p:txBody>
@@ -5013,7 +5013,7 @@
                 <a:latin typeface="Arial"/>
                 <a:ea typeface="Microsoft YaHei"/>
               </a:rPr>
-              <a:t>Agent 的位置：把业务问题变成可治理查询</a:t>
+              <a:t>桌面产品：把经营问题变成可信查询</a:t>
             </a:r>
           </a:p>
         </p:txBody>
@@ -5092,7 +5092,7 @@
                 <a:latin typeface="Arial"/>
                 <a:ea typeface="Microsoft YaHei"/>
               </a:rPr>
-              <a:t>统一语义层</a:t>
+              <a:t>电商指标层</a:t>
             </a:r>
           </a:p>
         </p:txBody>
@@ -5128,10 +5128,10 @@
                 <a:latin typeface="Arial"/>
                 <a:ea typeface="Microsoft YaHei"/>
               </a:rPr>
-              <a:t>业务语言 → 指标定义 → SQL
+              <a:t>经营语言 → 指标定义 → SQL
 不靠 LLM 临时猜表名
-分析师定义一次，全公司复用
-避免每次重新解释口径</a:t>
+订单、品类、渠道口径可复用
+避免每次重新解释数据</a:t>
             </a:r>
           </a:p>
         </p:txBody>
@@ -5328,7 +5328,7 @@
                 <a:latin typeface="Arial"/>
                 <a:ea typeface="Microsoft YaHei"/>
               </a:rPr>
-              <a:t>执行与治理边界</a:t>
+              <a:t>本地执行边界</a:t>
             </a:r>
           </a:p>
         </p:txBody>
@@ -5364,10 +5364,10 @@
                 <a:latin typeface="Arial"/>
                 <a:ea typeface="Microsoft YaHei"/>
               </a:rPr>
-              <a:t>Schema-only 模型暴露
-只读数据库连接
+              <a:t>本地 DB + 只读连接
+OpenAI-compatible endpoint/model/key
 AST 级 SQL 安全校验
-审计日志 + RBAC 路线图</a:t>
+token budget 留在本机</a:t>
             </a:r>
           </a:p>
         </p:txBody>
@@ -5403,7 +5403,7 @@
                 <a:latin typeface="Arial"/>
                 <a:ea typeface="Microsoft YaHei"/>
               </a:rPr>
-              <a:t>必要性：业务问题需要解释、验证和追问；单纯 SQL 生成无法承担治理责任</a:t>
+              <a:t>必要性：经营问题需要解释、验证和追问；单纯 SQL 生成无法承担分析责任</a:t>
             </a:r>
           </a:p>
         </p:txBody>
@@ -5465,7 +5465,7 @@
                 <a:latin typeface="Arial"/>
                 <a:ea typeface="Microsoft YaHei"/>
               </a:rPr>
-              <a:t>数据合规设计 — 企业买家最关心的问题</a:t>
+              <a:t>数据边界设计 — 本地工具也要可信</a:t>
             </a:r>
           </a:p>
         </p:txBody>
@@ -5505,7 +5505,7 @@
                 <a:latin typeface="Arial"/>
                 <a:ea typeface="Microsoft YaHei"/>
               </a:rPr>
-              <a:t>  —  Schema-only 模型暴露：LLM 只看到表名和列名，永远不接触原始数据</a:t>
+              <a:t>  —  默认暴露 schema；只把回答当前问题所需的查询结果交给模型解释</a:t>
             </a:r>
           </a:p>
           <a:p>
@@ -5573,7 +5573,7 @@
                 <a:latin typeface="Arial"/>
                 <a:ea typeface="Microsoft YaHei"/>
               </a:rPr>
-              <a:t>  —  生产路线图：行级安全（RLS）、PII 脱敏、审计日志、SSO/SAML</a:t>
+              <a:t>  —  OpenAI-compatible endpoint、model、API key、token budget 和数据连接都留在使用者本机</a:t>
             </a:r>
           </a:p>
         </p:txBody>
@@ -5609,7 +5609,7 @@
                 <a:latin typeface="Arial"/>
                 <a:ea typeface="Microsoft YaHei"/>
               </a:rPr>
-              <a:t>同样的架构模式：Snowflake Cortex、Databricks AI/BI 都采用'Schema-only + 只读执行'方案</a:t>
+              <a:t>关键不是替代模型，而是把外部模型 provider 接入受控数据、指标和执行边界</a:t>
             </a:r>
           </a:p>
         </p:txBody>
@@ -5707,7 +5707,7 @@
                 <a:latin typeface="Arial"/>
                 <a:ea typeface="Microsoft YaHei"/>
               </a:rPr>
-              <a:t>商业化路径：受治理的自助分析</a:t>
+              <a:t>商业化路径：广交会场景下的买断制工具</a:t>
             </a:r>
           </a:p>
         </p:txBody>
@@ -5786,7 +5786,7 @@
                 <a:latin typeface="Arial"/>
                 <a:ea typeface="Microsoft YaHei"/>
               </a:rPr>
-              <a:t>Phase 1: 可售 MVP（1-2周）</a:t>
+              <a:t>获客场景</a:t>
             </a:r>
           </a:p>
         </p:txBody>
@@ -5822,10 +5822,10 @@
                 <a:latin typeface="Arial"/>
                 <a:ea typeface="Microsoft YaHei"/>
               </a:rPr>
-              <a:t>SQLite → PostgreSQL 迁移
-NextAuth.js 用户认证
-语义层：指标定义 + Join 图
-审计日志 + 基础 RBAC</a:t>
+              <a:t>广交会周边地推 + 卖家社群投放
+亚马逊卖家、小工贸公司和外贸 SOHO
+现场扫码演示，几分钟看懂价值
+巴西 Olist 数据正好是海外市场样例</a:t>
             </a:r>
           </a:p>
         </p:txBody>
@@ -5904,7 +5904,7 @@
                 <a:latin typeface="Arial"/>
                 <a:ea typeface="Microsoft YaHei"/>
               </a:rPr>
-              <a:t>Phase 2: 企业试用（1-2月）</a:t>
+              <a:t>付费方式</a:t>
             </a:r>
           </a:p>
         </p:txBody>
@@ -5940,10 +5940,10 @@
                 <a:latin typeface="Arial"/>
                 <a:ea typeface="Microsoft YaHei"/>
               </a:rPr>
-              <a:t>SSO/SAML 集成
-行级安全 + PII 脱敏
-多数据源：PostgreSQL/BigQuery
-查询成本控制 + 取消机制</a:t>
+              <a:t>App Store / 官网一次买断
+建议首发价：¥128-168
+低于一次咨询或报表外包成本
+用户自带模型 API key，token 自付</a:t>
             </a:r>
           </a:p>
         </p:txBody>
@@ -6022,7 +6022,7 @@
                 <a:latin typeface="Arial"/>
                 <a:ea typeface="Microsoft YaHei"/>
               </a:rPr>
-              <a:t>Phase 3: 规模化（3-6月）</a:t>
+              <a:t>产品形态</a:t>
             </a:r>
           </a:p>
         </p:txBody>
@@ -6058,10 +6058,10 @@
                 <a:latin typeface="Arial"/>
                 <a:ea typeface="Microsoft YaHei"/>
               </a:rPr>
-              <a:t>Snowflake/Redshift/ClickHouse
-dbt 语义层集成
-指标认证 + 谱系追踪
-VPC 部署 + BYOM</a:t>
+              <a:t>个人开发者发布的 macOS 桌面工具
+员工在自己电脑里安装和运行
+Olist 是内置 demo case
+真实使用时连接本机可访问数据</a:t>
             </a:r>
           </a:p>
         </p:txBody>
@@ -6140,7 +6140,7 @@
                 <a:latin typeface="Arial"/>
                 <a:ea typeface="Microsoft YaHei"/>
               </a:rPr>
-              <a:t>商业模型</a:t>
+              <a:t>开发者机会</a:t>
             </a:r>
           </a:p>
         </p:txBody>
@@ -6176,10 +6176,10 @@
                 <a:latin typeface="Arial"/>
                 <a:ea typeface="Microsoft YaHei"/>
               </a:rPr>
-              <a:t>目标客户：数据团队、运营、市场
-付费点：席位、查询量、私有部署
-价值指标：请求周转时间、口径复用率
-从 MVP 到企业版：3 个月</a:t>
+              <a:t>卖点不是模型本身，而是电商分析流程
+无需后期云运维，边际成本低
+低决策成本，适合冲动购买
+用小额工具费换回高频时间成本</a:t>
             </a:r>
           </a:p>
         </p:txBody>
@@ -6241,7 +6241,7 @@
                 <a:latin typeface="Arial"/>
                 <a:ea typeface="Microsoft YaHei"/>
               </a:rPr>
-              <a:t>商业价值：自助速度 + 治理可信</a:t>
+              <a:t>商业价值：让小卖家也能问经营数据</a:t>
             </a:r>
           </a:p>
         </p:txBody>
@@ -6320,7 +6320,7 @@
                 <a:latin typeface="Arial"/>
                 <a:ea typeface="Microsoft YaHei"/>
               </a:rPr>
-              <a:t>数据团队</a:t>
+              <a:t>跨境电商小团队</a:t>
             </a:r>
           </a:p>
         </p:txBody>
@@ -6356,10 +6356,10 @@
                 <a:latin typeface="Arial"/>
                 <a:ea typeface="Microsoft YaHei"/>
               </a:rPr>
-              <a:t>减少重复取数和口径解释
-把精力放在语义层与治理
-统一指标资产，降低审计成本
-保留权限、血缘和执行边界</a:t>
+              <a:t>不用先搭 BI 或雇专职分析师
+围绕订单、品类、渠道连续追问
+快速判断海外市场和选品机会
+把常用问题沉淀成可复用指标</a:t>
             </a:r>
           </a:p>
         </p:txBody>
@@ -6438,7 +6438,7 @@
                 <a:latin typeface="Arial"/>
                 <a:ea typeface="Microsoft YaHei"/>
               </a:rPr>
-              <a:t>业务团队</a:t>
+              <a:t>个人开发者</a:t>
             </a:r>
           </a:p>
         </p:txBody>
@@ -6474,10 +6474,10 @@
                 <a:latin typeface="Arial"/>
                 <a:ea typeface="Microsoft YaHei"/>
               </a:rPr>
-              <a:t>不用排队等临时报表
-围绕同一数据连续追问
-在销售、投放、品类上更快试错
-从看结果转向做决策</a:t>
+              <a:t>不出售模型能力，只出售好用流程
+用户自带 provider key，成本边界清楚
+买断制降低试用门槛
+广交会等线下场景便于直接触达用户</a:t>
             </a:r>
           </a:p>
         </p:txBody>
@@ -6513,7 +6513,7 @@
                 <a:latin typeface="Arial"/>
                 <a:ea typeface="Microsoft YaHei"/>
               </a:rPr>
-              <a:t>不是替代分析师，而是把分析师定义的标准放进业务日常决策</a:t>
+              <a:t>Olist 巴西电商数据用于公开 demo；真实价值是把小卖家已有经营数据变成可追问的分析工作台</a:t>
             </a:r>
           </a:p>
         </p:txBody>

</xml_diff>

<commit_message>
Prepare local desktop release
</commit_message>
<xml_diff>
--- a/assets/QueryForge-Pitch.pptx
+++ b/assets/QueryForge-Pitch.pptx
@@ -3244,7 +3244,7 @@
                 <a:latin typeface="Arial"/>
                 <a:ea typeface="Microsoft YaHei"/>
               </a:rPr>
-              <a:t>面向跨境电商小团队的 local-first macOS 分析工作台</a:t>
+              <a:t>面向跨境电商小团队的本地优先经营工具包 · 首个工具：订单分析 workbench</a:t>
             </a:r>
           </a:p>
         </p:txBody>
@@ -3961,7 +3961,7 @@
                 <a:latin typeface="Arial"/>
                 <a:ea typeface="Microsoft YaHei"/>
               </a:rPr>
-              <a:t>  —  桌面 macOS app 是真实产品，数据连接与 API key 留在本机</a:t>
+              <a:t>  —  当前 demo 是 macOS 本地包；产品形态可扩展到 Windows/macOS 预编译软件包</a:t>
             </a:r>
           </a:p>
         </p:txBody>
@@ -4915,7 +4915,7 @@
                 <a:latin typeface="Arial"/>
                 <a:ea typeface="Microsoft YaHei"/>
               </a:rPr>
-              <a:t>  —  数据包含订单、支付、商品、评价、物流全链路</a:t>
+              <a:t>  —  数据包含订单、支付、商品、客户地区和品类结构</a:t>
             </a:r>
           </a:p>
         </p:txBody>
@@ -4951,7 +4951,7 @@
                 <a:latin typeface="Arial"/>
                 <a:ea typeface="Microsoft YaHei"/>
               </a:rPr>
-              <a:t>Railway / iPhone QR 是 polished public demo；完整产品是本地 macOS app</a:t>
+              <a:t>Railway / iPhone QR 是 polished public demo；完整产品路径是本地桌面软件包</a:t>
             </a:r>
           </a:p>
         </p:txBody>
@@ -5365,7 +5365,7 @@
                 <a:ea typeface="Microsoft YaHei"/>
               </a:rPr>
               <a:t>本地 DB + 只读连接
-OpenAI-compatible endpoint/model/key
+用户自选模型服务与 key
 AST 级 SQL 安全校验
 token budget 留在本机</a:t>
             </a:r>
@@ -5465,21 +5465,64 @@
                 <a:latin typeface="Arial"/>
                 <a:ea typeface="Microsoft YaHei"/>
               </a:rPr>
-              <a:t>数据边界设计 — 本地工具也要可信</a:t>
-            </a:r>
-          </a:p>
-        </p:txBody>
-      </p:sp>
-      <p:sp>
-        <p:nvSpPr>
-          <p:cNvPr id="3" name="TextBox 2"/>
+              <a:t>数据与模型边界 — 本地工具也要可信</a:t>
+            </a:r>
+          </a:p>
+        </p:txBody>
+      </p:sp>
+      <p:sp>
+        <p:nvSpPr>
+          <p:cNvPr id="3" name="Rounded Rectangle 2"/>
+          <p:cNvSpPr/>
+          <p:nvPr/>
+        </p:nvSpPr>
+        <p:spPr>
+          <a:xfrm>
+            <a:off x="914400" y="1600200"/>
+            <a:ext cx="5029200" cy="2011680"/>
+          </a:xfrm>
+          <a:prstGeom prst="roundRect">
+            <a:avLst/>
+          </a:prstGeom>
+          <a:solidFill>
+            <a:srgbClr val="2A2F3E"/>
+          </a:solidFill>
+          <a:ln>
+            <a:noFill/>
+          </a:ln>
+        </p:spPr>
+        <p:style>
+          <a:lnRef idx="1">
+            <a:schemeClr val="accent1"/>
+          </a:lnRef>
+          <a:fillRef idx="3">
+            <a:schemeClr val="accent1"/>
+          </a:fillRef>
+          <a:effectRef idx="2">
+            <a:schemeClr val="accent1"/>
+          </a:effectRef>
+          <a:fontRef idx="minor">
+            <a:schemeClr val="lt1"/>
+          </a:fontRef>
+        </p:style>
+        <p:txBody>
+          <a:bodyPr rtlCol="0" anchor="ctr"/>
+          <a:lstStyle/>
+          <a:p>
+            <a:pPr algn="ctr"/>
+          </a:p>
+        </p:txBody>
+      </p:sp>
+      <p:sp>
+        <p:nvSpPr>
+          <p:cNvPr id="4" name="TextBox 3"/>
           <p:cNvSpPr txBox="1"/>
           <p:nvPr/>
         </p:nvSpPr>
         <p:spPr>
           <a:xfrm>
-            <a:off x="914400" y="1828800"/>
-            <a:ext cx="9144000" cy="2514600"/>
+            <a:off x="1188720" y="1783080"/>
+            <a:ext cx="4480560" cy="365760"/>
           </a:xfrm>
           <a:prstGeom prst="rect">
             <a:avLst/>
@@ -5492,102 +5535,30 @@
           </a:bodyPr>
           <a:lstStyle/>
           <a:p>
-            <a:pPr algn="l">
-              <a:spcAft>
-                <a:spcPts val="1400"/>
-              </a:spcAft>
-            </a:pPr>
-            <a:r>
-              <a:rPr sz="1500">
-                <a:solidFill>
-                  <a:srgbClr val="F0EEE8"/>
-                </a:solidFill>
-                <a:latin typeface="Arial"/>
-                <a:ea typeface="Microsoft YaHei"/>
-              </a:rPr>
-              <a:t>  —  默认暴露 schema；只把回答当前问题所需的查询结果交给模型解释</a:t>
-            </a:r>
-          </a:p>
-          <a:p>
-            <a:pPr algn="l">
-              <a:spcAft>
-                <a:spcPts val="1400"/>
-              </a:spcAft>
-            </a:pPr>
-            <a:r>
-              <a:rPr sz="1500">
-                <a:solidFill>
-                  <a:srgbClr val="F0EEE8"/>
-                </a:solidFill>
-                <a:latin typeface="Arial"/>
-                <a:ea typeface="Microsoft YaHei"/>
-              </a:rPr>
-              <a:t>  —  AST 级 SQL 验证：用 node-sql-parser 解析 SQL 语法树，只允许 SELECT 查询</a:t>
-            </a:r>
-          </a:p>
-          <a:p>
-            <a:pPr algn="l">
-              <a:spcAft>
-                <a:spcPts val="1400"/>
-              </a:spcAft>
-            </a:pPr>
-            <a:r>
-              <a:rPr sz="1500">
-                <a:solidFill>
-                  <a:srgbClr val="F0EEE8"/>
-                </a:solidFill>
-                <a:latin typeface="Arial"/>
-                <a:ea typeface="Microsoft YaHei"/>
-              </a:rPr>
-              <a:t>  —  只读数据库连接：数据库层面配置 readonly 模式，即使代码有漏洞也无法写入</a:t>
-            </a:r>
-          </a:p>
-          <a:p>
-            <a:pPr algn="l">
-              <a:spcAft>
-                <a:spcPts val="1400"/>
-              </a:spcAft>
-            </a:pPr>
-            <a:r>
-              <a:rPr sz="1500">
-                <a:solidFill>
-                  <a:srgbClr val="F0EEE8"/>
-                </a:solidFill>
-                <a:latin typeface="Arial"/>
-                <a:ea typeface="Microsoft YaHei"/>
-              </a:rPr>
-              <a:t>  —  自动 LIMIT 注入：LLM 忘记加 LIMIT 时自动补全，防止全表扫描</a:t>
-            </a:r>
-          </a:p>
-          <a:p>
-            <a:pPr algn="l">
-              <a:spcAft>
-                <a:spcPts val="1400"/>
-              </a:spcAft>
-            </a:pPr>
-            <a:r>
-              <a:rPr sz="1500">
-                <a:solidFill>
-                  <a:srgbClr val="F0EEE8"/>
-                </a:solidFill>
-                <a:latin typeface="Arial"/>
-                <a:ea typeface="Microsoft YaHei"/>
-              </a:rPr>
-              <a:t>  —  OpenAI-compatible endpoint、model、API key、token budget 和数据连接都留在使用者本机</a:t>
-            </a:r>
-          </a:p>
-        </p:txBody>
-      </p:sp>
-      <p:sp>
-        <p:nvSpPr>
-          <p:cNvPr id="4" name="TextBox 3"/>
+            <a:pPr algn="l"/>
+            <a:r>
+              <a:rPr sz="1600" b="1">
+                <a:solidFill>
+                  <a:srgbClr val="D4A853"/>
+                </a:solidFill>
+                <a:latin typeface="Arial"/>
+                <a:ea typeface="Microsoft YaHei"/>
+              </a:rPr>
+              <a:t>数据边界</a:t>
+            </a:r>
+          </a:p>
+        </p:txBody>
+      </p:sp>
+      <p:sp>
+        <p:nvSpPr>
+          <p:cNvPr id="5" name="TextBox 4"/>
           <p:cNvSpPr txBox="1"/>
           <p:nvPr/>
         </p:nvSpPr>
         <p:spPr>
           <a:xfrm>
-            <a:off x="914400" y="4754880"/>
-            <a:ext cx="9144000" cy="457200"/>
+            <a:off x="1188720" y="2240280"/>
+            <a:ext cx="4480560" cy="1097280"/>
           </a:xfrm>
           <a:prstGeom prst="rect">
             <a:avLst/>
@@ -5602,21 +5573,376 @@
           <a:p>
             <a:pPr algn="l"/>
             <a:r>
-              <a:rPr sz="1300" b="0">
+              <a:rPr sz="1400" b="0">
+                <a:solidFill>
+                  <a:srgbClr val="F0EEE8"/>
+                </a:solidFill>
+                <a:latin typeface="Arial"/>
+                <a:ea typeface="Microsoft YaHei"/>
+              </a:rPr>
+              <a:t>默认只暴露 schema
+只把当前问题所需查询结果交给模型解释
+AST 校验只允许 SELECT
+自动 LIMIT，避免全表扫描</a:t>
+            </a:r>
+          </a:p>
+        </p:txBody>
+      </p:sp>
+      <p:sp>
+        <p:nvSpPr>
+          <p:cNvPr id="6" name="Rounded Rectangle 5"/>
+          <p:cNvSpPr/>
+          <p:nvPr/>
+        </p:nvSpPr>
+        <p:spPr>
+          <a:xfrm>
+            <a:off x="6217920" y="1600200"/>
+            <a:ext cx="5029200" cy="2011680"/>
+          </a:xfrm>
+          <a:prstGeom prst="roundRect">
+            <a:avLst/>
+          </a:prstGeom>
+          <a:solidFill>
+            <a:srgbClr val="2A2F3E"/>
+          </a:solidFill>
+          <a:ln>
+            <a:noFill/>
+          </a:ln>
+        </p:spPr>
+        <p:style>
+          <a:lnRef idx="1">
+            <a:schemeClr val="accent1"/>
+          </a:lnRef>
+          <a:fillRef idx="3">
+            <a:schemeClr val="accent1"/>
+          </a:fillRef>
+          <a:effectRef idx="2">
+            <a:schemeClr val="accent1"/>
+          </a:effectRef>
+          <a:fontRef idx="minor">
+            <a:schemeClr val="lt1"/>
+          </a:fontRef>
+        </p:style>
+        <p:txBody>
+          <a:bodyPr rtlCol="0" anchor="ctr"/>
+          <a:lstStyle/>
+          <a:p>
+            <a:pPr algn="ctr"/>
+          </a:p>
+        </p:txBody>
+      </p:sp>
+      <p:sp>
+        <p:nvSpPr>
+          <p:cNvPr id="7" name="TextBox 6"/>
+          <p:cNvSpPr txBox="1"/>
+          <p:nvPr/>
+        </p:nvSpPr>
+        <p:spPr>
+          <a:xfrm>
+            <a:off x="6492240" y="1783080"/>
+            <a:ext cx="4480560" cy="365760"/>
+          </a:xfrm>
+          <a:prstGeom prst="rect">
+            <a:avLst/>
+          </a:prstGeom>
+          <a:noFill/>
+        </p:spPr>
+        <p:txBody>
+          <a:bodyPr wrap="square">
+            <a:spAutoFit/>
+          </a:bodyPr>
+          <a:lstStyle/>
+          <a:p>
+            <a:pPr algn="l"/>
+            <a:r>
+              <a:rPr sz="1600" b="1">
                 <a:solidFill>
                   <a:srgbClr val="D4A853"/>
                 </a:solidFill>
                 <a:latin typeface="Arial"/>
                 <a:ea typeface="Microsoft YaHei"/>
               </a:rPr>
-              <a:t>关键不是替代模型，而是把外部模型 provider 接入受控数据、指标和执行边界</a:t>
-            </a:r>
-          </a:p>
-        </p:txBody>
-      </p:sp>
-      <p:sp>
-        <p:nvSpPr>
-          <p:cNvPr id="5" name="TextBox 4"/>
+              <a:t>BYOK 边界</a:t>
+            </a:r>
+          </a:p>
+        </p:txBody>
+      </p:sp>
+      <p:sp>
+        <p:nvSpPr>
+          <p:cNvPr id="8" name="TextBox 7"/>
+          <p:cNvSpPr txBox="1"/>
+          <p:nvPr/>
+        </p:nvSpPr>
+        <p:spPr>
+          <a:xfrm>
+            <a:off x="6492240" y="2240280"/>
+            <a:ext cx="4480560" cy="1097280"/>
+          </a:xfrm>
+          <a:prstGeom prst="rect">
+            <a:avLst/>
+          </a:prstGeom>
+          <a:noFill/>
+        </p:spPr>
+        <p:txBody>
+          <a:bodyPr wrap="square">
+            <a:spAutoFit/>
+          </a:bodyPr>
+          <a:lstStyle/>
+          <a:p>
+            <a:pPr algn="l"/>
+            <a:r>
+              <a:rPr sz="1400" b="0">
+                <a:solidFill>
+                  <a:srgbClr val="F0EEE8"/>
+                </a:solidFill>
+                <a:latin typeface="Arial"/>
+                <a:ea typeface="Microsoft YaHei"/>
+              </a:rPr>
+              <a:t>用户自带 provider key/token
+QueryForge 不转售模型能力
+公开 QR demo 不收集访客 key
+真实调用只在本地桌面端发生</a:t>
+            </a:r>
+          </a:p>
+        </p:txBody>
+      </p:sp>
+      <p:sp>
+        <p:nvSpPr>
+          <p:cNvPr id="9" name="Rounded Rectangle 8"/>
+          <p:cNvSpPr/>
+          <p:nvPr/>
+        </p:nvSpPr>
+        <p:spPr>
+          <a:xfrm>
+            <a:off x="914400" y="3886200"/>
+            <a:ext cx="5029200" cy="1828800"/>
+          </a:xfrm>
+          <a:prstGeom prst="roundRect">
+            <a:avLst/>
+          </a:prstGeom>
+          <a:solidFill>
+            <a:srgbClr val="2A2F3E"/>
+          </a:solidFill>
+          <a:ln>
+            <a:noFill/>
+          </a:ln>
+        </p:spPr>
+        <p:style>
+          <a:lnRef idx="1">
+            <a:schemeClr val="accent1"/>
+          </a:lnRef>
+          <a:fillRef idx="3">
+            <a:schemeClr val="accent1"/>
+          </a:fillRef>
+          <a:effectRef idx="2">
+            <a:schemeClr val="accent1"/>
+          </a:effectRef>
+          <a:fontRef idx="minor">
+            <a:schemeClr val="lt1"/>
+          </a:fontRef>
+        </p:style>
+        <p:txBody>
+          <a:bodyPr rtlCol="0" anchor="ctr"/>
+          <a:lstStyle/>
+          <a:p>
+            <a:pPr algn="ctr"/>
+          </a:p>
+        </p:txBody>
+      </p:sp>
+      <p:sp>
+        <p:nvSpPr>
+          <p:cNvPr id="10" name="TextBox 9"/>
+          <p:cNvSpPr txBox="1"/>
+          <p:nvPr/>
+        </p:nvSpPr>
+        <p:spPr>
+          <a:xfrm>
+            <a:off x="1188720" y="4069080"/>
+            <a:ext cx="4480560" cy="365760"/>
+          </a:xfrm>
+          <a:prstGeom prst="rect">
+            <a:avLst/>
+          </a:prstGeom>
+          <a:noFill/>
+        </p:spPr>
+        <p:txBody>
+          <a:bodyPr wrap="square">
+            <a:spAutoFit/>
+          </a:bodyPr>
+          <a:lstStyle/>
+          <a:p>
+            <a:pPr algn="l"/>
+            <a:r>
+              <a:rPr sz="1600" b="1">
+                <a:solidFill>
+                  <a:srgbClr val="D4A853"/>
+                </a:solidFill>
+                <a:latin typeface="Arial"/>
+                <a:ea typeface="Microsoft YaHei"/>
+              </a:rPr>
+              <a:t>商用输出依据</a:t>
+            </a:r>
+          </a:p>
+        </p:txBody>
+      </p:sp>
+      <p:sp>
+        <p:nvSpPr>
+          <p:cNvPr id="11" name="TextBox 10"/>
+          <p:cNvSpPr txBox="1"/>
+          <p:nvPr/>
+        </p:nvSpPr>
+        <p:spPr>
+          <a:xfrm>
+            <a:off x="1188720" y="4526280"/>
+            <a:ext cx="4480560" cy="914400"/>
+          </a:xfrm>
+          <a:prstGeom prst="rect">
+            <a:avLst/>
+          </a:prstGeom>
+          <a:noFill/>
+        </p:spPr>
+        <p:txBody>
+          <a:bodyPr wrap="square">
+            <a:spAutoFit/>
+          </a:bodyPr>
+          <a:lstStyle/>
+          <a:p>
+            <a:pPr algn="l"/>
+            <a:r>
+              <a:rPr sz="1400" b="0">
+                <a:solidFill>
+                  <a:srgbClr val="F0EEE8"/>
+                </a:solidFill>
+                <a:latin typeface="Arial"/>
+                <a:ea typeface="Microsoft YaHei"/>
+              </a:rPr>
+              <a:t>OpenAI：用户保留 Input 权利并拥有 Output
+Anthropic：商业条款说明客户保留输出权利
+DeepSeek / Kimi：强调用户对输入、输出和授权负责</a:t>
+            </a:r>
+          </a:p>
+        </p:txBody>
+      </p:sp>
+      <p:sp>
+        <p:nvSpPr>
+          <p:cNvPr id="12" name="Rounded Rectangle 11"/>
+          <p:cNvSpPr/>
+          <p:nvPr/>
+        </p:nvSpPr>
+        <p:spPr>
+          <a:xfrm>
+            <a:off x="6217920" y="3886200"/>
+            <a:ext cx="5029200" cy="1828800"/>
+          </a:xfrm>
+          <a:prstGeom prst="roundRect">
+            <a:avLst/>
+          </a:prstGeom>
+          <a:solidFill>
+            <a:srgbClr val="2A2F3E"/>
+          </a:solidFill>
+          <a:ln>
+            <a:noFill/>
+          </a:ln>
+        </p:spPr>
+        <p:style>
+          <a:lnRef idx="1">
+            <a:schemeClr val="accent1"/>
+          </a:lnRef>
+          <a:fillRef idx="3">
+            <a:schemeClr val="accent1"/>
+          </a:fillRef>
+          <a:effectRef idx="2">
+            <a:schemeClr val="accent1"/>
+          </a:effectRef>
+          <a:fontRef idx="minor">
+            <a:schemeClr val="lt1"/>
+          </a:fontRef>
+        </p:style>
+        <p:txBody>
+          <a:bodyPr rtlCol="0" anchor="ctr"/>
+          <a:lstStyle/>
+          <a:p>
+            <a:pPr algn="ctr"/>
+          </a:p>
+        </p:txBody>
+      </p:sp>
+      <p:sp>
+        <p:nvSpPr>
+          <p:cNvPr id="13" name="TextBox 12"/>
+          <p:cNvSpPr txBox="1"/>
+          <p:nvPr/>
+        </p:nvSpPr>
+        <p:spPr>
+          <a:xfrm>
+            <a:off x="6492240" y="4069080"/>
+            <a:ext cx="4480560" cy="365760"/>
+          </a:xfrm>
+          <a:prstGeom prst="rect">
+            <a:avLst/>
+          </a:prstGeom>
+          <a:noFill/>
+        </p:spPr>
+        <p:txBody>
+          <a:bodyPr wrap="square">
+            <a:spAutoFit/>
+          </a:bodyPr>
+          <a:lstStyle/>
+          <a:p>
+            <a:pPr algn="l"/>
+            <a:r>
+              <a:rPr sz="1600" b="1">
+                <a:solidFill>
+                  <a:srgbClr val="D4A853"/>
+                </a:solidFill>
+                <a:latin typeface="Arial"/>
+                <a:ea typeface="Microsoft YaHei"/>
+              </a:rPr>
+              <a:t>使用者责任</a:t>
+            </a:r>
+          </a:p>
+        </p:txBody>
+      </p:sp>
+      <p:sp>
+        <p:nvSpPr>
+          <p:cNvPr id="14" name="TextBox 13"/>
+          <p:cNvSpPr txBox="1"/>
+          <p:nvPr/>
+        </p:nvSpPr>
+        <p:spPr>
+          <a:xfrm>
+            <a:off x="6492240" y="4526280"/>
+            <a:ext cx="4480560" cy="914400"/>
+          </a:xfrm>
+          <a:prstGeom prst="rect">
+            <a:avLst/>
+          </a:prstGeom>
+          <a:noFill/>
+        </p:spPr>
+        <p:txBody>
+          <a:bodyPr wrap="square">
+            <a:spAutoFit/>
+          </a:bodyPr>
+          <a:lstStyle/>
+          <a:p>
+            <a:pPr algn="l"/>
+            <a:r>
+              <a:rPr sz="1400" b="0">
+                <a:solidFill>
+                  <a:srgbClr val="F0EEE8"/>
+                </a:solidFill>
+                <a:latin typeface="Arial"/>
+                <a:ea typeface="Microsoft YaHei"/>
+              </a:rPr>
+              <a:t>老板分析自己的经营数据通常边界清楚
+个人信息、平台限制字段、第三方素材和商业秘密仍需确认权利
+输出建议不是法律/财务意见</a:t>
+            </a:r>
+          </a:p>
+        </p:txBody>
+      </p:sp>
+      <p:sp>
+        <p:nvSpPr>
+          <p:cNvPr id="15" name="TextBox 14"/>
           <p:cNvSpPr txBox="1"/>
           <p:nvPr/>
         </p:nvSpPr>
@@ -5645,7 +5971,7 @@
                 <a:latin typeface="Arial"/>
                 <a:ea typeface="Microsoft YaHei"/>
               </a:rPr>
-              <a:t>QueryForge 不给 LLM 数据库权限 · AI 生成 SQL，数据库执行查询，策略引擎控制访问</a:t>
+              <a:t>合规叙述：接入用户自己的模型账户和经营数据，不替用户绕过 provider ToS、平台条款或知识产权限制</a:t>
             </a:r>
           </a:p>
         </p:txBody>
@@ -5707,7 +6033,7 @@
                 <a:latin typeface="Arial"/>
                 <a:ea typeface="Microsoft YaHei"/>
               </a:rPr>
-              <a:t>商业化路径：广交会场景下的买断制工具</a:t>
+              <a:t>商业化路径：服务小微电商的软件包</a:t>
             </a:r>
           </a:p>
         </p:txBody>
@@ -5940,7 +6266,7 @@
                 <a:latin typeface="Arial"/>
                 <a:ea typeface="Microsoft YaHei"/>
               </a:rPr>
-              <a:t>App Store / 官网一次买断
+              <a:t>官网/渠道/应用商店售卖闭源预编译包
 建议首发价：¥128-168
 低于一次咨询或报表外包成本
 用户自带模型 API key，token 自付</a:t>
@@ -6058,8 +6384,8 @@
                 <a:latin typeface="Arial"/>
                 <a:ea typeface="Microsoft YaHei"/>
               </a:rPr>
-              <a:t>个人开发者发布的 macOS 桌面工具
-员工在自己电脑里安装和运行
+              <a:t>工具包首个工具：订单经营分析
+当前 demo 为 macOS，本质不限定平台
 Olist 是内置 demo case
 真实使用时连接本机可访问数据</a:t>
             </a:r>
@@ -6513,7 +6839,7 @@
                 <a:latin typeface="Arial"/>
                 <a:ea typeface="Microsoft YaHei"/>
               </a:rPr>
-              <a:t>Olist 巴西电商数据用于公开 demo；真实价值是把小卖家已有经营数据变成可追问的分析工作台</a:t>
+              <a:t>Olist 巴西电商数据用于公开 demo；真实价值是把小卖家已有经营数据变成可追问的工具包</a:t>
             </a:r>
           </a:p>
         </p:txBody>

</xml_diff>